<commit_message>
Agrega graficos con datos reales a la seccion de hallazgos
Parte de la version editada por el usuario y reemplaza la diapositiva de
hallazgos por tres, bajo el mismo numeral III segun la convencion del
deck de referencia: magnitud (indice 2010=100), distribucion dentro del
mes (retiros y depositos por dia al cierre) y composicion por entidad
(participacion anual). Los tres graficos son nativos de PowerPoint y se
calculan sobre las series del one-pager.

El hallazgo de composicion pasa a medirse como participacion en los
retiros del sistema, acotada a 0-100, en lugar de la participacion en el
neto, que supera 800 % en algun ano y no es graficable.

Co-Authored-By: Claude <noreply@anthropic.com>
Claude-Session: https://claude.ai/code/session_01SURmUuM52wCTGgqjrg54Xk
</commit_message>
<xml_diff>
--- a/Requerimientos_de_Liquidez.pptx
+++ b/Requerimientos_de_Liquidez.pptx
@@ -4,20 +4,23 @@
   <p:sldMasterIdLst>
     <p:sldMasterId id="2147483648" r:id="rId1"/>
   </p:sldMasterIdLst>
+  <p:notesMasterIdLst>
+    <p:notesMasterId r:id="rId12"/>
+  </p:notesMasterIdLst>
   <p:sldIdLst>
-    <p:sldId id="256" r:id="rId2"/>
+    <p:sldId id="266" r:id="rId2"/>
     <p:sldId id="257" r:id="rId3"/>
     <p:sldId id="258" r:id="rId4"/>
     <p:sldId id="259" r:id="rId5"/>
+    <p:sldId id="267" r:id="rId17"/>
+    <p:sldId id="268" r:id="rId18"/>
     <p:sldId id="260" r:id="rId6"/>
     <p:sldId id="261" r:id="rId7"/>
     <p:sldId id="262" r:id="rId8"/>
     <p:sldId id="263" r:id="rId9"/>
     <p:sldId id="264" r:id="rId10"/>
+    <p:sldId id="265" r:id="rId11"/>
   </p:sldIdLst>
-  <p:notesMasterIdLst>
-    <p:notesMasterId r:id="rId11"/>
-  </p:notesMasterIdLst>
   <p:sldSz cx="12192000" cy="6858000"/>
   <p:notesSz cx="6858000" cy="12192000"/>
   <p:defaultTextStyle>
@@ -112,7 +115,866 @@
       </a:defRPr>
     </a:lvl9pPr>
   </p:defaultTextStyle>
+  <p:extLst>
+    <p:ext uri="{EFAFB233-063F-42B5-8137-9DF3F51BA10A}">
+      <p15:sldGuideLst xmlns:p15="http://schemas.microsoft.com/office/powerpoint/2012/main"/>
+    </p:ext>
+  </p:extLst>
 </p:presentation>
+</file>
+
+<file path=ppt/charts/chart1.xml><?xml version="1.0" encoding="utf-8"?>
+<c:chartSpace xmlns:c="http://schemas.openxmlformats.org/drawingml/2006/chart" xmlns:a="http://schemas.openxmlformats.org/drawingml/2006/main" xmlns:r="http://schemas.openxmlformats.org/officeDocument/2006/relationships">
+  <c:date1904 val="0"/>
+  <c:chart>
+    <c:autoTitleDeleted val="1"/>
+    <c:plotArea>
+      <c:barChart>
+        <c:barDir val="col"/>
+        <c:grouping val="clustered"/>
+        <c:varyColors val="0"/>
+        <c:ser>
+          <c:idx val="0"/>
+          <c:order val="0"/>
+          <c:tx>
+            <c:strRef>
+              <c:f>Sheet1!$B$1</c:f>
+              <c:strCache>
+                <c:ptCount val="1"/>
+                <c:pt idx="0">
+                  <c:v>Índice</c:v>
+                </c:pt>
+              </c:strCache>
+            </c:strRef>
+          </c:tx>
+          <c:spPr>
+            <a:solidFill>
+              <a:srgbClr val="073269"/>
+            </a:solidFill>
+            <a:ln>
+              <a:noFill/>
+            </a:ln>
+          </c:spPr>
+          <c:cat>
+            <c:strRef>
+              <c:f>Sheet1!$A$2:$A$17</c:f>
+              <c:strCache>
+                <c:ptCount val="16"/>
+                <c:pt idx="0">
+                  <c:v>2010</c:v>
+                </c:pt>
+                <c:pt idx="1">
+                  <c:v>2011</c:v>
+                </c:pt>
+                <c:pt idx="2">
+                  <c:v>2012</c:v>
+                </c:pt>
+                <c:pt idx="3">
+                  <c:v>2013</c:v>
+                </c:pt>
+                <c:pt idx="4">
+                  <c:v>2014</c:v>
+                </c:pt>
+                <c:pt idx="5">
+                  <c:v>2015</c:v>
+                </c:pt>
+                <c:pt idx="6">
+                  <c:v>2016</c:v>
+                </c:pt>
+                <c:pt idx="7">
+                  <c:v>2017</c:v>
+                </c:pt>
+                <c:pt idx="8">
+                  <c:v>2018</c:v>
+                </c:pt>
+                <c:pt idx="9">
+                  <c:v>2019</c:v>
+                </c:pt>
+                <c:pt idx="10">
+                  <c:v>2020</c:v>
+                </c:pt>
+                <c:pt idx="11">
+                  <c:v>2021</c:v>
+                </c:pt>
+                <c:pt idx="12">
+                  <c:v>2022</c:v>
+                </c:pt>
+                <c:pt idx="13">
+                  <c:v>2023</c:v>
+                </c:pt>
+                <c:pt idx="14">
+                  <c:v>2024</c:v>
+                </c:pt>
+                <c:pt idx="15">
+                  <c:v>2025</c:v>
+                </c:pt>
+              </c:strCache>
+            </c:strRef>
+          </c:cat>
+          <c:val>
+            <c:numRef>
+              <c:f>Sheet1!$B$2:$B$17</c:f>
+              <c:numCache>
+                <c:formatCode>General</c:formatCode>
+                <c:ptCount val="16"/>
+                <c:pt idx="0">
+                  <c:v>100.0</c:v>
+                </c:pt>
+                <c:pt idx="1">
+                  <c:v>63.3</c:v>
+                </c:pt>
+                <c:pt idx="2">
+                  <c:v>-65.7</c:v>
+                </c:pt>
+                <c:pt idx="3">
+                  <c:v>85.5</c:v>
+                </c:pt>
+                <c:pt idx="4">
+                  <c:v>111.0</c:v>
+                </c:pt>
+                <c:pt idx="5">
+                  <c:v>147.8</c:v>
+                </c:pt>
+                <c:pt idx="6">
+                  <c:v>117.4</c:v>
+                </c:pt>
+                <c:pt idx="7">
+                  <c:v>27.9</c:v>
+                </c:pt>
+                <c:pt idx="8">
+                  <c:v>265.0</c:v>
+                </c:pt>
+                <c:pt idx="9">
+                  <c:v>277.6</c:v>
+                </c:pt>
+                <c:pt idx="10">
+                  <c:v>522.1</c:v>
+                </c:pt>
+                <c:pt idx="11">
+                  <c:v>249.5</c:v>
+                </c:pt>
+                <c:pt idx="12">
+                  <c:v>596.8</c:v>
+                </c:pt>
+                <c:pt idx="13">
+                  <c:v>542.8</c:v>
+                </c:pt>
+                <c:pt idx="14">
+                  <c:v>1040.4</c:v>
+                </c:pt>
+                <c:pt idx="15">
+                  <c:v>1151.4</c:v>
+                </c:pt>
+              </c:numCache>
+            </c:numRef>
+          </c:val>
+        </c:ser>
+        <c:gapWidth val="60"/>
+        <c:axId val="-2068027336"/>
+        <c:axId val="-2113994440"/>
+      </c:barChart>
+      <c:catAx>
+        <c:axId val="-2068027336"/>
+        <c:scaling>
+          <c:orientation val="minMax"/>
+        </c:scaling>
+        <c:delete val="0"/>
+        <c:axPos val="b"/>
+        <c:majorTickMark val="none"/>
+        <c:minorTickMark val="none"/>
+        <c:tickLblPos val="nextTo"/>
+        <c:spPr>
+          <a:ln>
+            <a:solidFill>
+              <a:srgbClr val="D8DEE8"/>
+            </a:solidFill>
+          </a:ln>
+        </c:spPr>
+        <c:txPr>
+          <a:bodyPr/>
+          <a:lstStyle/>
+          <a:p>
+            <a:pPr>
+              <a:defRPr sz="1100">
+                <a:solidFill>
+                  <a:srgbClr val="767676"/>
+                </a:solidFill>
+                <a:latin typeface="Calibri"/>
+              </a:defRPr>
+            </a:pPr>
+          </a:p>
+        </c:txPr>
+        <c:crossAx val="-2113994440"/>
+        <c:crosses val="autoZero"/>
+        <c:auto val="1"/>
+        <c:lblAlgn val="ctr"/>
+        <c:lblOffset val="100"/>
+        <c:noMultiLvlLbl val="0"/>
+      </c:catAx>
+      <c:valAx>
+        <c:axId val="-2113994440"/>
+        <c:scaling/>
+        <c:delete val="0"/>
+        <c:axPos val="l"/>
+        <c:majorGridlines>
+          <c:spPr>
+            <a:ln w="9525">
+              <a:solidFill>
+                <a:srgbClr val="D8DEE8"/>
+              </a:solidFill>
+            </a:ln>
+          </c:spPr>
+        </c:majorGridlines>
+        <c:majorTickMark val="out"/>
+        <c:minorTickMark val="none"/>
+        <c:tickLblPos val="nextTo"/>
+        <c:spPr>
+          <a:ln>
+            <a:solidFill>
+              <a:srgbClr val="D8DEE8"/>
+            </a:solidFill>
+          </a:ln>
+        </c:spPr>
+        <c:txPr>
+          <a:bodyPr/>
+          <a:lstStyle/>
+          <a:p>
+            <a:pPr>
+              <a:defRPr sz="1100">
+                <a:solidFill>
+                  <a:srgbClr val="767676"/>
+                </a:solidFill>
+                <a:latin typeface="Calibri"/>
+              </a:defRPr>
+            </a:pPr>
+          </a:p>
+        </c:txPr>
+        <c:crossAx val="-2068027336"/>
+        <c:crosses val="autoZero"/>
+      </c:valAx>
+    </c:plotArea>
+    <c:dispBlanksAs val="gap"/>
+  </c:chart>
+  <c:txPr>
+    <a:bodyPr/>
+    <a:lstStyle/>
+    <a:p>
+      <a:pPr>
+        <a:defRPr sz="1100">
+          <a:solidFill>
+            <a:srgbClr val="767676"/>
+          </a:solidFill>
+          <a:latin typeface="Calibri"/>
+        </a:defRPr>
+      </a:pPr>
+      <a:endParaRPr lang="en-US"/>
+    </a:p>
+  </c:txPr>
+  <c:externalData r:id="rId1">
+    <c:autoUpdate val="0"/>
+  </c:externalData>
+</c:chartSpace>
+</file>
+
+<file path=ppt/charts/chart2.xml><?xml version="1.0" encoding="utf-8"?>
+<c:chartSpace xmlns:c="http://schemas.openxmlformats.org/drawingml/2006/chart" xmlns:a="http://schemas.openxmlformats.org/drawingml/2006/main" xmlns:r="http://schemas.openxmlformats.org/officeDocument/2006/relationships">
+  <c:date1904 val="0"/>
+  <c:chart>
+    <c:autoTitleDeleted val="1"/>
+    <c:plotArea>
+      <c:barChart>
+        <c:barDir val="col"/>
+        <c:grouping val="clustered"/>
+        <c:varyColors val="0"/>
+        <c:ser>
+          <c:idx val="0"/>
+          <c:order val="0"/>
+          <c:tx>
+            <c:strRef>
+              <c:f>Sheet1!$B$1</c:f>
+              <c:strCache>
+                <c:ptCount val="1"/>
+                <c:pt idx="0">
+                  <c:v>Retiros</c:v>
+                </c:pt>
+              </c:strCache>
+            </c:strRef>
+          </c:tx>
+          <c:spPr>
+            <a:solidFill>
+              <a:srgbClr val="073269"/>
+            </a:solidFill>
+            <a:ln>
+              <a:noFill/>
+            </a:ln>
+          </c:spPr>
+          <c:cat>
+            <c:strRef>
+              <c:f>Sheet1!$A$2:$A$12</c:f>
+              <c:strCache>
+                <c:ptCount val="11"/>
+                <c:pt idx="0">
+                  <c:v>10</c:v>
+                </c:pt>
+                <c:pt idx="1">
+                  <c:v>9</c:v>
+                </c:pt>
+                <c:pt idx="2">
+                  <c:v>8</c:v>
+                </c:pt>
+                <c:pt idx="3">
+                  <c:v>7</c:v>
+                </c:pt>
+                <c:pt idx="4">
+                  <c:v>6</c:v>
+                </c:pt>
+                <c:pt idx="5">
+                  <c:v>5</c:v>
+                </c:pt>
+                <c:pt idx="6">
+                  <c:v>4</c:v>
+                </c:pt>
+                <c:pt idx="7">
+                  <c:v>3</c:v>
+                </c:pt>
+                <c:pt idx="8">
+                  <c:v>2</c:v>
+                </c:pt>
+                <c:pt idx="9">
+                  <c:v>1</c:v>
+                </c:pt>
+                <c:pt idx="10">
+                  <c:v>cierre</c:v>
+                </c:pt>
+              </c:strCache>
+            </c:strRef>
+          </c:cat>
+          <c:val>
+            <c:numRef>
+              <c:f>Sheet1!$B$2:$B$12</c:f>
+              <c:numCache>
+                <c:formatCode>General</c:formatCode>
+                <c:ptCount val="11"/>
+                <c:pt idx="0">
+                  <c:v>4.286769230769232</c:v>
+                </c:pt>
+                <c:pt idx="1">
+                  <c:v>4.441046153846154</c:v>
+                </c:pt>
+                <c:pt idx="2">
+                  <c:v>4.897630769230769</c:v>
+                </c:pt>
+                <c:pt idx="3">
+                  <c:v>4.4761999999999995</c:v>
+                </c:pt>
+                <c:pt idx="4">
+                  <c:v>4.2929076923076925</c:v>
+                </c:pt>
+                <c:pt idx="5">
+                  <c:v>4.4199230769230775</c:v>
+                </c:pt>
+                <c:pt idx="6">
+                  <c:v>4.324707692307692</c:v>
+                </c:pt>
+                <c:pt idx="7">
+                  <c:v>5.075107692307691</c:v>
+                </c:pt>
+                <c:pt idx="8">
+                  <c:v>5.940246153846154</c:v>
+                </c:pt>
+                <c:pt idx="9">
+                  <c:v>6.154876923076923</c:v>
+                </c:pt>
+                <c:pt idx="10">
+                  <c:v>10.341600000000001</c:v>
+                </c:pt>
+              </c:numCache>
+            </c:numRef>
+          </c:val>
+        </c:ser>
+        <c:ser>
+          <c:idx val="1"/>
+          <c:order val="1"/>
+          <c:tx>
+            <c:strRef>
+              <c:f>Sheet1!$C$1</c:f>
+              <c:strCache>
+                <c:ptCount val="1"/>
+                <c:pt idx="0">
+                  <c:v>Depósitos</c:v>
+                </c:pt>
+              </c:strCache>
+            </c:strRef>
+          </c:tx>
+          <c:spPr>
+            <a:solidFill>
+              <a:srgbClr val="C8A24B"/>
+            </a:solidFill>
+            <a:ln>
+              <a:noFill/>
+            </a:ln>
+          </c:spPr>
+          <c:cat>
+            <c:strRef>
+              <c:f>Sheet1!$A$2:$A$12</c:f>
+              <c:strCache>
+                <c:ptCount val="11"/>
+                <c:pt idx="0">
+                  <c:v>10</c:v>
+                </c:pt>
+                <c:pt idx="1">
+                  <c:v>9</c:v>
+                </c:pt>
+                <c:pt idx="2">
+                  <c:v>8</c:v>
+                </c:pt>
+                <c:pt idx="3">
+                  <c:v>7</c:v>
+                </c:pt>
+                <c:pt idx="4">
+                  <c:v>6</c:v>
+                </c:pt>
+                <c:pt idx="5">
+                  <c:v>5</c:v>
+                </c:pt>
+                <c:pt idx="6">
+                  <c:v>4</c:v>
+                </c:pt>
+                <c:pt idx="7">
+                  <c:v>3</c:v>
+                </c:pt>
+                <c:pt idx="8">
+                  <c:v>2</c:v>
+                </c:pt>
+                <c:pt idx="9">
+                  <c:v>1</c:v>
+                </c:pt>
+                <c:pt idx="10">
+                  <c:v>cierre</c:v>
+                </c:pt>
+              </c:strCache>
+            </c:strRef>
+          </c:cat>
+          <c:val>
+            <c:numRef>
+              <c:f>Sheet1!$C$2:$C$12</c:f>
+              <c:numCache>
+                <c:formatCode>General</c:formatCode>
+                <c:ptCount val="11"/>
+                <c:pt idx="0">
+                  <c:v>4.8388307692307695</c:v>
+                </c:pt>
+                <c:pt idx="1">
+                  <c:v>4.383461538461539</c:v>
+                </c:pt>
+                <c:pt idx="2">
+                  <c:v>4.402784615384615</c:v>
+                </c:pt>
+                <c:pt idx="3">
+                  <c:v>4.425584615384616</c:v>
+                </c:pt>
+                <c:pt idx="4">
+                  <c:v>4.038446153846152</c:v>
+                </c:pt>
+                <c:pt idx="5">
+                  <c:v>4.4548</c:v>
+                </c:pt>
+                <c:pt idx="6">
+                  <c:v>4.818907692307693</c:v>
+                </c:pt>
+                <c:pt idx="7">
+                  <c:v>4.0336307692307685</c:v>
+                </c:pt>
+                <c:pt idx="8">
+                  <c:v>3.9652923076923083</c:v>
+                </c:pt>
+                <c:pt idx="9">
+                  <c:v>4.175015384615385</c:v>
+                </c:pt>
+                <c:pt idx="10">
+                  <c:v>5.033799999999999</c:v>
+                </c:pt>
+              </c:numCache>
+            </c:numRef>
+          </c:val>
+        </c:ser>
+        <c:gapWidth val="80"/>
+        <c:axId val="-2068027336"/>
+        <c:axId val="-2113994440"/>
+      </c:barChart>
+      <c:catAx>
+        <c:axId val="-2068027336"/>
+        <c:scaling>
+          <c:orientation val="minMax"/>
+        </c:scaling>
+        <c:delete val="0"/>
+        <c:axPos val="b"/>
+        <c:majorTickMark val="none"/>
+        <c:minorTickMark val="none"/>
+        <c:tickLblPos val="nextTo"/>
+        <c:spPr>
+          <a:ln>
+            <a:solidFill>
+              <a:srgbClr val="D8DEE8"/>
+            </a:solidFill>
+          </a:ln>
+        </c:spPr>
+        <c:txPr>
+          <a:bodyPr/>
+          <a:lstStyle/>
+          <a:p>
+            <a:pPr>
+              <a:defRPr sz="1100">
+                <a:solidFill>
+                  <a:srgbClr val="767676"/>
+                </a:solidFill>
+                <a:latin typeface="Calibri"/>
+              </a:defRPr>
+            </a:pPr>
+          </a:p>
+        </c:txPr>
+        <c:crossAx val="-2113994440"/>
+        <c:crosses val="autoZero"/>
+        <c:auto val="1"/>
+        <c:lblAlgn val="ctr"/>
+        <c:lblOffset val="100"/>
+        <c:noMultiLvlLbl val="0"/>
+      </c:catAx>
+      <c:valAx>
+        <c:axId val="-2113994440"/>
+        <c:scaling/>
+        <c:delete val="0"/>
+        <c:axPos val="l"/>
+        <c:majorGridlines>
+          <c:spPr>
+            <a:ln w="9525">
+              <a:solidFill>
+                <a:srgbClr val="D8DEE8"/>
+              </a:solidFill>
+            </a:ln>
+          </c:spPr>
+        </c:majorGridlines>
+        <c:numFmt formatCode="0&quot;%&quot;" sourceLinked="0"/>
+        <c:majorTickMark val="out"/>
+        <c:minorTickMark val="none"/>
+        <c:tickLblPos val="nextTo"/>
+        <c:spPr>
+          <a:ln>
+            <a:solidFill>
+              <a:srgbClr val="D8DEE8"/>
+            </a:solidFill>
+          </a:ln>
+        </c:spPr>
+        <c:txPr>
+          <a:bodyPr/>
+          <a:lstStyle/>
+          <a:p>
+            <a:pPr>
+              <a:defRPr sz="1100">
+                <a:solidFill>
+                  <a:srgbClr val="767676"/>
+                </a:solidFill>
+                <a:latin typeface="Calibri"/>
+              </a:defRPr>
+            </a:pPr>
+          </a:p>
+        </c:txPr>
+        <c:crossAx val="-2068027336"/>
+        <c:crosses val="autoZero"/>
+      </c:valAx>
+    </c:plotArea>
+    <c:legend>
+      <c:legendPos val="b"/>
+      <c:overlay val="0"/>
+      <c:txPr>
+        <a:bodyPr/>
+        <a:lstStyle/>
+        <a:p>
+          <a:pPr>
+            <a:defRPr sz="1100">
+              <a:solidFill>
+                <a:srgbClr val="002060"/>
+              </a:solidFill>
+            </a:defRPr>
+          </a:pPr>
+        </a:p>
+      </c:txPr>
+    </c:legend>
+    <c:dispBlanksAs val="gap"/>
+  </c:chart>
+  <c:txPr>
+    <a:bodyPr/>
+    <a:lstStyle/>
+    <a:p>
+      <a:pPr>
+        <a:defRPr sz="1100">
+          <a:solidFill>
+            <a:srgbClr val="767676"/>
+          </a:solidFill>
+          <a:latin typeface="Calibri"/>
+        </a:defRPr>
+      </a:pPr>
+      <a:endParaRPr lang="en-US"/>
+    </a:p>
+  </c:txPr>
+  <c:externalData r:id="rId1">
+    <c:autoUpdate val="0"/>
+  </c:externalData>
+</c:chartSpace>
+</file>
+
+<file path=ppt/charts/chart3.xml><?xml version="1.0" encoding="utf-8"?>
+<c:chartSpace xmlns:c="http://schemas.openxmlformats.org/drawingml/2006/chart" xmlns:a="http://schemas.openxmlformats.org/drawingml/2006/main" xmlns:r="http://schemas.openxmlformats.org/officeDocument/2006/relationships">
+  <c:date1904 val="0"/>
+  <c:chart>
+    <c:autoTitleDeleted val="1"/>
+    <c:plotArea>
+      <c:barChart>
+        <c:barDir val="col"/>
+        <c:grouping val="clustered"/>
+        <c:varyColors val="0"/>
+        <c:ser>
+          <c:idx val="0"/>
+          <c:order val="0"/>
+          <c:tx>
+            <c:strRef>
+              <c:f>Sheet1!$B$1</c:f>
+              <c:strCache>
+                <c:ptCount val="1"/>
+                <c:pt idx="0">
+                  <c:v>Participación</c:v>
+                </c:pt>
+              </c:strCache>
+            </c:strRef>
+          </c:tx>
+          <c:spPr>
+            <a:solidFill>
+              <a:srgbClr val="073269"/>
+            </a:solidFill>
+            <a:ln>
+              <a:noFill/>
+            </a:ln>
+          </c:spPr>
+          <c:cat>
+            <c:strRef>
+              <c:f>Sheet1!$A$2:$A$17</c:f>
+              <c:strCache>
+                <c:ptCount val="16"/>
+                <c:pt idx="0">
+                  <c:v>2010</c:v>
+                </c:pt>
+                <c:pt idx="1">
+                  <c:v>2011</c:v>
+                </c:pt>
+                <c:pt idx="2">
+                  <c:v>2012</c:v>
+                </c:pt>
+                <c:pt idx="3">
+                  <c:v>2013</c:v>
+                </c:pt>
+                <c:pt idx="4">
+                  <c:v>2014</c:v>
+                </c:pt>
+                <c:pt idx="5">
+                  <c:v>2015</c:v>
+                </c:pt>
+                <c:pt idx="6">
+                  <c:v>2016</c:v>
+                </c:pt>
+                <c:pt idx="7">
+                  <c:v>2017</c:v>
+                </c:pt>
+                <c:pt idx="8">
+                  <c:v>2018</c:v>
+                </c:pt>
+                <c:pt idx="9">
+                  <c:v>2019</c:v>
+                </c:pt>
+                <c:pt idx="10">
+                  <c:v>2020</c:v>
+                </c:pt>
+                <c:pt idx="11">
+                  <c:v>2021</c:v>
+                </c:pt>
+                <c:pt idx="12">
+                  <c:v>2022</c:v>
+                </c:pt>
+                <c:pt idx="13">
+                  <c:v>2023</c:v>
+                </c:pt>
+                <c:pt idx="14">
+                  <c:v>2024</c:v>
+                </c:pt>
+                <c:pt idx="15">
+                  <c:v>2025</c:v>
+                </c:pt>
+              </c:strCache>
+            </c:strRef>
+          </c:cat>
+          <c:val>
+            <c:numRef>
+              <c:f>Sheet1!$B$2:$B$17</c:f>
+              <c:numCache>
+                <c:formatCode>General</c:formatCode>
+                <c:ptCount val="16"/>
+                <c:pt idx="0">
+                  <c:v>10.475</c:v>
+                </c:pt>
+                <c:pt idx="1">
+                  <c:v>38.59975</c:v>
+                </c:pt>
+                <c:pt idx="2">
+                  <c:v>17.04725</c:v>
+                </c:pt>
+                <c:pt idx="3">
+                  <c:v>48.15875</c:v>
+                </c:pt>
+                <c:pt idx="4">
+                  <c:v>47.60975</c:v>
+                </c:pt>
+                <c:pt idx="5">
+                  <c:v>37.69125</c:v>
+                </c:pt>
+                <c:pt idx="6">
+                  <c:v>52.44975</c:v>
+                </c:pt>
+                <c:pt idx="7">
+                  <c:v>70.72725</c:v>
+                </c:pt>
+                <c:pt idx="8">
+                  <c:v>34.0595</c:v>
+                </c:pt>
+                <c:pt idx="9">
+                  <c:v>64.56625</c:v>
+                </c:pt>
+                <c:pt idx="10">
+                  <c:v>82.0715</c:v>
+                </c:pt>
+                <c:pt idx="11">
+                  <c:v>27.21575</c:v>
+                </c:pt>
+                <c:pt idx="12">
+                  <c:v>72.625</c:v>
+                </c:pt>
+                <c:pt idx="13">
+                  <c:v>70.15225</c:v>
+                </c:pt>
+                <c:pt idx="14">
+                  <c:v>85.88</c:v>
+                </c:pt>
+                <c:pt idx="15">
+                  <c:v>81.81875</c:v>
+                </c:pt>
+              </c:numCache>
+            </c:numRef>
+          </c:val>
+        </c:ser>
+        <c:gapWidth val="60"/>
+        <c:axId val="-2068027336"/>
+        <c:axId val="-2113994440"/>
+      </c:barChart>
+      <c:catAx>
+        <c:axId val="-2068027336"/>
+        <c:scaling>
+          <c:orientation val="minMax"/>
+        </c:scaling>
+        <c:delete val="0"/>
+        <c:axPos val="b"/>
+        <c:majorTickMark val="none"/>
+        <c:minorTickMark val="none"/>
+        <c:tickLblPos val="nextTo"/>
+        <c:spPr>
+          <a:ln>
+            <a:solidFill>
+              <a:srgbClr val="D8DEE8"/>
+            </a:solidFill>
+          </a:ln>
+        </c:spPr>
+        <c:txPr>
+          <a:bodyPr/>
+          <a:lstStyle/>
+          <a:p>
+            <a:pPr>
+              <a:defRPr sz="1100">
+                <a:solidFill>
+                  <a:srgbClr val="767676"/>
+                </a:solidFill>
+                <a:latin typeface="Calibri"/>
+              </a:defRPr>
+            </a:pPr>
+          </a:p>
+        </c:txPr>
+        <c:crossAx val="-2113994440"/>
+        <c:crosses val="autoZero"/>
+        <c:auto val="1"/>
+        <c:lblAlgn val="ctr"/>
+        <c:lblOffset val="100"/>
+        <c:noMultiLvlLbl val="0"/>
+      </c:catAx>
+      <c:valAx>
+        <c:axId val="-2113994440"/>
+        <c:scaling/>
+        <c:delete val="0"/>
+        <c:axPos val="l"/>
+        <c:majorGridlines>
+          <c:spPr>
+            <a:ln w="9525">
+              <a:solidFill>
+                <a:srgbClr val="D8DEE8"/>
+              </a:solidFill>
+            </a:ln>
+          </c:spPr>
+        </c:majorGridlines>
+        <c:numFmt formatCode="0&quot;%&quot;" sourceLinked="0"/>
+        <c:majorTickMark val="out"/>
+        <c:minorTickMark val="none"/>
+        <c:tickLblPos val="nextTo"/>
+        <c:spPr>
+          <a:ln>
+            <a:solidFill>
+              <a:srgbClr val="D8DEE8"/>
+            </a:solidFill>
+          </a:ln>
+        </c:spPr>
+        <c:txPr>
+          <a:bodyPr/>
+          <a:lstStyle/>
+          <a:p>
+            <a:pPr>
+              <a:defRPr sz="1100">
+                <a:solidFill>
+                  <a:srgbClr val="767676"/>
+                </a:solidFill>
+                <a:latin typeface="Calibri"/>
+              </a:defRPr>
+            </a:pPr>
+          </a:p>
+        </c:txPr>
+        <c:crossAx val="-2068027336"/>
+        <c:crosses val="autoZero"/>
+      </c:valAx>
+    </c:plotArea>
+    <c:dispBlanksAs val="gap"/>
+  </c:chart>
+  <c:txPr>
+    <a:bodyPr/>
+    <a:lstStyle/>
+    <a:p>
+      <a:pPr>
+        <a:defRPr sz="1100">
+          <a:solidFill>
+            <a:srgbClr val="767676"/>
+          </a:solidFill>
+          <a:latin typeface="Calibri"/>
+        </a:defRPr>
+      </a:pPr>
+      <a:endParaRPr lang="en-US"/>
+    </a:p>
+  </c:txPr>
+  <c:externalData r:id="rId1">
+    <c:autoUpdate val="0"/>
+  </c:externalData>
+</c:chartSpace>
 </file>
 
 <file path=ppt/notesMasters/notesMaster1.xml><?xml version="1.0" encoding="utf-8"?>
@@ -137,234 +999,10 @@
           <a:chExt cx="0" cy="0"/>
         </a:xfrm>
       </p:grpSpPr>
-      <p:sp>
-        <p:nvSpPr>
-          <p:cNvPr id="2" name="Header Placeholder 1"/>
-          <p:cNvSpPr>
-            <a:spLocks noGrp="1"/>
-          </p:cNvSpPr>
-          <p:nvPr>
-            <p:ph type="hdr" sz="quarter"/>
-          </p:nvPr>
-        </p:nvSpPr>
-        <p:spPr>
-          <a:xfrm>
-            <a:off x="0" y="0"/>
-            <a:ext cx="2971800" cy="458788"/>
-          </a:xfrm>
-          <a:prstGeom prst="rect">
-            <a:avLst/>
-          </a:prstGeom>
-        </p:spPr>
-        <p:txBody>
-          <a:bodyPr vert="horz" lIns="91440" tIns="45720" rIns="91440" bIns="45720" rtlCol="0"/>
-          <a:lstStyle>
-            <a:lvl1pPr algn="l">
-              <a:defRPr sz="1200"/>
-            </a:lvl1pPr>
-          </a:lstStyle>
-          <a:p>
-            <a:endParaRPr lang="en-US"/>
-          </a:p>
-        </p:txBody>
-      </p:sp>
-      <p:sp>
-        <p:nvSpPr>
-          <p:cNvPr id="3" name="Date Placeholder 2"/>
-          <p:cNvSpPr>
-            <a:spLocks noGrp="1"/>
-          </p:cNvSpPr>
-          <p:nvPr>
-            <p:ph type="dt" idx="1"/>
-          </p:nvPr>
-        </p:nvSpPr>
-        <p:spPr>
-          <a:xfrm>
-            <a:off x="3884613" y="0"/>
-            <a:ext cx="2971800" cy="458788"/>
-          </a:xfrm>
-          <a:prstGeom prst="rect">
-            <a:avLst/>
-          </a:prstGeom>
-        </p:spPr>
-        <p:txBody>
-          <a:bodyPr vert="horz" lIns="91440" tIns="45720" rIns="91440" bIns="45720" rtlCol="0"/>
-          <a:lstStyle>
-            <a:lvl1pPr algn="r">
-              <a:defRPr sz="1200"/>
-            </a:lvl1pPr>
-          </a:lstStyle>
-          <a:p>
-            <a:fld id="{5282F153-3F37-0F45-9E97-73ACFA13230C}" type="datetimeFigureOut">
-              <a:rPr lang="en-US"/>
-              <a:t>7/23/19</a:t>
-            </a:fld>
-            <a:endParaRPr lang="en-US"/>
-          </a:p>
-        </p:txBody>
-      </p:sp>
-      <p:sp>
-        <p:nvSpPr>
-          <p:cNvPr id="4" name="Slide Image Placeholder 3"/>
-          <p:cNvSpPr>
-            <a:spLocks noGrp="1" noRot="1" noChangeAspect="1"/>
-          </p:cNvSpPr>
-          <p:nvPr>
-            <p:ph type="sldImg" idx="2"/>
-          </p:nvPr>
-        </p:nvSpPr>
-        <p:spPr>
-          <a:xfrm>
-            <a:off x="685800" y="1143000"/>
-            <a:ext cx="5486400" cy="3086100"/>
-          </a:xfrm>
-          <a:prstGeom prst="rect">
-            <a:avLst/>
-          </a:prstGeom>
-          <a:noFill/>
-          <a:ln w="12700">
-            <a:solidFill>
-              <a:prstClr val="black"/>
-            </a:solidFill>
-          </a:ln>
-        </p:spPr>
-        <p:txBody>
-          <a:bodyPr vert="horz" lIns="91440" tIns="45720" rIns="91440" bIns="45720" rtlCol="0" anchor="ctr"/>
-          <a:lstStyle/>
-          <a:p>
-            <a:endParaRPr lang="en-US"/>
-          </a:p>
-        </p:txBody>
-      </p:sp>
-      <p:sp>
-        <p:nvSpPr>
-          <p:cNvPr id="5" name="Notes Placeholder 4"/>
-          <p:cNvSpPr>
-            <a:spLocks noGrp="1"/>
-          </p:cNvSpPr>
-          <p:nvPr>
-            <p:ph type="body" sz="quarter" idx="3"/>
-          </p:nvPr>
-        </p:nvSpPr>
-        <p:spPr>
-          <a:xfrm>
-            <a:off x="685800" y="4400550"/>
-            <a:ext cx="5486400" cy="3600450"/>
-          </a:xfrm>
-          <a:prstGeom prst="rect">
-            <a:avLst/>
-          </a:prstGeom>
-        </p:spPr>
-        <p:txBody>
-          <a:bodyPr vert="horz" lIns="91440" tIns="45720" rIns="91440" bIns="45720" rtlCol="0"/>
-          <a:lstStyle/>
-          <a:p>
-            <a:pPr lvl="0"/>
-            <a:r>
-              <a:rPr lang="en-US"/>
-              <a:t>Click to edit Master text styles</a:t>
-            </a:r>
-          </a:p>
-          <a:p>
-            <a:pPr lvl="1"/>
-            <a:r>
-              <a:rPr lang="en-US"/>
-              <a:t>Second level</a:t>
-            </a:r>
-          </a:p>
-          <a:p>
-            <a:pPr lvl="2"/>
-            <a:r>
-              <a:rPr lang="en-US"/>
-              <a:t>Third level</a:t>
-            </a:r>
-          </a:p>
-          <a:p>
-            <a:pPr lvl="3"/>
-            <a:r>
-              <a:rPr lang="en-US"/>
-              <a:t>Fourth level</a:t>
-            </a:r>
-          </a:p>
-          <a:p>
-            <a:pPr lvl="4"/>
-            <a:r>
-              <a:rPr lang="en-US"/>
-              <a:t>Fifth level</a:t>
-            </a:r>
-          </a:p>
-        </p:txBody>
-      </p:sp>
-      <p:sp>
-        <p:nvSpPr>
-          <p:cNvPr id="6" name="Footer Placeholder 5"/>
-          <p:cNvSpPr>
-            <a:spLocks noGrp="1"/>
-          </p:cNvSpPr>
-          <p:nvPr>
-            <p:ph type="ftr" sz="quarter" idx="4"/>
-          </p:nvPr>
-        </p:nvSpPr>
-        <p:spPr>
-          <a:xfrm>
-            <a:off x="0" y="8685213"/>
-            <a:ext cx="2971800" cy="458787"/>
-          </a:xfrm>
-          <a:prstGeom prst="rect">
-            <a:avLst/>
-          </a:prstGeom>
-        </p:spPr>
-        <p:txBody>
-          <a:bodyPr vert="horz" lIns="91440" tIns="45720" rIns="91440" bIns="45720" rtlCol="0" anchor="b"/>
-          <a:lstStyle>
-            <a:lvl1pPr algn="l">
-              <a:defRPr sz="1200"/>
-            </a:lvl1pPr>
-          </a:lstStyle>
-          <a:p>
-            <a:endParaRPr lang="en-US"/>
-          </a:p>
-        </p:txBody>
-      </p:sp>
-      <p:sp>
-        <p:nvSpPr>
-          <p:cNvPr id="7" name="Slide Number Placeholder 6"/>
-          <p:cNvSpPr>
-            <a:spLocks noGrp="1"/>
-          </p:cNvSpPr>
-          <p:nvPr>
-            <p:ph type="sldNum" sz="quarter" idx="5"/>
-          </p:nvPr>
-        </p:nvSpPr>
-        <p:spPr>
-          <a:xfrm>
-            <a:off x="3884613" y="8685213"/>
-            <a:ext cx="2971800" cy="458787"/>
-          </a:xfrm>
-          <a:prstGeom prst="rect">
-            <a:avLst/>
-          </a:prstGeom>
-        </p:spPr>
-        <p:txBody>
-          <a:bodyPr vert="horz" lIns="91440" tIns="45720" rIns="91440" bIns="45720" rtlCol="0" anchor="b"/>
-          <a:lstStyle>
-            <a:lvl1pPr algn="r">
-              <a:defRPr sz="1200"/>
-            </a:lvl1pPr>
-          </a:lstStyle>
-          <a:p>
-            <a:fld id="{CE5E9CC1-C706-0F49-92D6-E571CC5EEA8F}" type="slidenum">
-              <a:rPr lang="en-US"/>
-              <a:t>‹#›</a:t>
-            </a:fld>
-            <a:endParaRPr lang="en-US"/>
-          </a:p>
-        </p:txBody>
-      </p:sp>
     </p:spTree>
     <p:extLst>
       <p:ext uri="{BB962C8B-B14F-4D97-AF65-F5344CB8AC3E}">
-        <p14:creationId xmlns:p14="http://schemas.microsoft.com/office/powerpoint/2010/main" val="1024086991"/>
+        <p14:creationId xmlns:p14="http://schemas.microsoft.com/office/powerpoint/2010/main" val="3626281912"/>
       </p:ext>
     </p:extLst>
   </p:cSld>
@@ -469,7 +1107,13 @@
   <p:cSld>
     <p:spTree>
       <p:nvGrpSpPr>
-        <p:cNvPr id="1" name=""/>
+        <p:cNvPr id="1" name="">
+          <a:extLst>
+            <a:ext uri="{FF2B5EF4-FFF2-40B4-BE49-F238E27FC236}">
+              <a16:creationId xmlns:a16="http://schemas.microsoft.com/office/drawing/2014/main" id="{F814D1DD-D8AB-BDF9-AE31-13A4E8F4AF55}"/>
+            </a:ext>
+          </a:extLst>
+        </p:cNvPr>
         <p:cNvGrpSpPr/>
         <p:nvPr/>
       </p:nvGrpSpPr>
@@ -483,7 +1127,13 @@
       </p:grpSpPr>
       <p:sp>
         <p:nvSpPr>
-          <p:cNvPr id="2" name="Slide Image Placeholder 1"/>
+          <p:cNvPr id="2" name="Slide Image Placeholder 1">
+            <a:extLst>
+              <a:ext uri="{FF2B5EF4-FFF2-40B4-BE49-F238E27FC236}">
+                <a16:creationId xmlns:a16="http://schemas.microsoft.com/office/drawing/2014/main" id="{9946EED5-B302-5823-0721-124E64F63DD1}"/>
+              </a:ext>
+            </a:extLst>
+          </p:cNvPr>
           <p:cNvSpPr>
             <a:spLocks noGrp="1" noRot="1" noChangeAspect="1"/>
           </p:cNvSpPr>
@@ -495,7 +1145,13 @@
       </p:sp>
       <p:sp>
         <p:nvSpPr>
-          <p:cNvPr id="3" name="Notes Placeholder 2"/>
+          <p:cNvPr id="3" name="Notes Placeholder 2">
+            <a:extLst>
+              <a:ext uri="{FF2B5EF4-FFF2-40B4-BE49-F238E27FC236}">
+                <a16:creationId xmlns:a16="http://schemas.microsoft.com/office/drawing/2014/main" id="{A4CF20EB-2BCE-C5B1-F78A-FD435ECF0A87}"/>
+              </a:ext>
+            </a:extLst>
+          </p:cNvPr>
           <p:cNvSpPr>
             <a:spLocks noGrp="1"/>
           </p:cNvSpPr>
@@ -512,13 +1168,18 @@
               <a:rPr lang="en-US" dirty="0"/>
               <a:t>Confirmar el departamento emisor antes de presentar.</a:t>
             </a:r>
-            <a:endParaRPr lang="en-US" dirty="0"/>
-          </a:p>
-        </p:txBody>
-      </p:sp>
-      <p:sp>
-        <p:nvSpPr>
-          <p:cNvPr id="4" name="Slide Number Placeholder 3"/>
+          </a:p>
+        </p:txBody>
+      </p:sp>
+      <p:sp>
+        <p:nvSpPr>
+          <p:cNvPr id="4" name="Slide Number Placeholder 3">
+            <a:extLst>
+              <a:ext uri="{FF2B5EF4-FFF2-40B4-BE49-F238E27FC236}">
+                <a16:creationId xmlns:a16="http://schemas.microsoft.com/office/drawing/2014/main" id="{2C096FB5-BC7E-F561-FA25-03D2CBD41E38}"/>
+              </a:ext>
+            </a:extLst>
+          </p:cNvPr>
           <p:cNvSpPr>
             <a:spLocks noGrp="1"/>
           </p:cNvSpPr>
@@ -542,7 +1203,118 @@
     </p:spTree>
     <p:extLst>
       <p:ext uri="{BB962C8B-B14F-4D97-AF65-F5344CB8AC3E}">
-        <p14:creationId xmlns:p14="http://schemas.microsoft.com/office/powerpoint/2010/main" val="1024086991"/>
+        <p14:creationId xmlns:p14="http://schemas.microsoft.com/office/powerpoint/2010/main" val="2888725395"/>
+      </p:ext>
+    </p:extLst>
+  </p:cSld>
+  <p:clrMapOvr>
+    <a:masterClrMapping/>
+  </p:clrMapOvr>
+</p:notes>
+</file>
+
+<file path=ppt/notesSlides/notesSlide10.xml><?xml version="1.0" encoding="utf-8"?>
+<p:notes xmlns:a="http://schemas.openxmlformats.org/drawingml/2006/main" xmlns:r="http://schemas.openxmlformats.org/officeDocument/2006/relationships" xmlns:p="http://schemas.openxmlformats.org/presentationml/2006/main">
+  <p:cSld>
+    <p:spTree>
+      <p:nvGrpSpPr>
+        <p:cNvPr id="1" name="">
+          <a:extLst>
+            <a:ext uri="{FF2B5EF4-FFF2-40B4-BE49-F238E27FC236}">
+              <a16:creationId xmlns:a16="http://schemas.microsoft.com/office/drawing/2014/main" id="{AC5DBF23-2B02-D357-C21C-F23DA5737A63}"/>
+            </a:ext>
+          </a:extLst>
+        </p:cNvPr>
+        <p:cNvGrpSpPr/>
+        <p:nvPr/>
+      </p:nvGrpSpPr>
+      <p:grpSpPr>
+        <a:xfrm>
+          <a:off x="0" y="0"/>
+          <a:ext cx="0" cy="0"/>
+          <a:chOff x="0" y="0"/>
+          <a:chExt cx="0" cy="0"/>
+        </a:xfrm>
+      </p:grpSpPr>
+      <p:sp>
+        <p:nvSpPr>
+          <p:cNvPr id="2" name="Slide Image Placeholder 1">
+            <a:extLst>
+              <a:ext uri="{FF2B5EF4-FFF2-40B4-BE49-F238E27FC236}">
+                <a16:creationId xmlns:a16="http://schemas.microsoft.com/office/drawing/2014/main" id="{4A11807D-6095-2055-EFBC-E0DF0CCEC5AC}"/>
+              </a:ext>
+            </a:extLst>
+          </p:cNvPr>
+          <p:cNvSpPr>
+            <a:spLocks noGrp="1" noRot="1" noChangeAspect="1"/>
+          </p:cNvSpPr>
+          <p:nvPr>
+            <p:ph type="sldImg"/>
+          </p:nvPr>
+        </p:nvSpPr>
+        <p:spPr/>
+      </p:sp>
+      <p:sp>
+        <p:nvSpPr>
+          <p:cNvPr id="3" name="Notes Placeholder 2">
+            <a:extLst>
+              <a:ext uri="{FF2B5EF4-FFF2-40B4-BE49-F238E27FC236}">
+                <a16:creationId xmlns:a16="http://schemas.microsoft.com/office/drawing/2014/main" id="{82B2052A-CA1F-4B47-6F1D-84C9884404B5}"/>
+              </a:ext>
+            </a:extLst>
+          </p:cNvPr>
+          <p:cNvSpPr>
+            <a:spLocks noGrp="1"/>
+          </p:cNvSpPr>
+          <p:nvPr>
+            <p:ph type="body" idx="1"/>
+          </p:nvPr>
+        </p:nvSpPr>
+        <p:spPr/>
+        <p:txBody>
+          <a:bodyPr/>
+          <a:lstStyle/>
+          <a:p>
+            <a:r>
+              <a:rPr lang="en-US" dirty="0"/>
+              <a:t>Confirmar el departamento emisor antes de presentar.</a:t>
+            </a:r>
+          </a:p>
+        </p:txBody>
+      </p:sp>
+      <p:sp>
+        <p:nvSpPr>
+          <p:cNvPr id="4" name="Slide Number Placeholder 3">
+            <a:extLst>
+              <a:ext uri="{FF2B5EF4-FFF2-40B4-BE49-F238E27FC236}">
+                <a16:creationId xmlns:a16="http://schemas.microsoft.com/office/drawing/2014/main" id="{07D3F675-6F23-D05F-80AF-F79E8FBFBCDF}"/>
+              </a:ext>
+            </a:extLst>
+          </p:cNvPr>
+          <p:cNvSpPr>
+            <a:spLocks noGrp="1"/>
+          </p:cNvSpPr>
+          <p:nvPr>
+            <p:ph type="sldNum" sz="quarter" idx="10"/>
+          </p:nvPr>
+        </p:nvSpPr>
+        <p:spPr/>
+        <p:txBody>
+          <a:bodyPr/>
+          <a:lstStyle/>
+          <a:p>
+            <a:fld id="{F7021451-1387-4CA6-816F-3879F97B5CBC}" type="slidenum">
+              <a:rPr lang="en-US"/>
+              <a:t>10</a:t>
+            </a:fld>
+            <a:endParaRPr lang="en-US"/>
+          </a:p>
+        </p:txBody>
+      </p:sp>
+    </p:spTree>
+    <p:extLst>
+      <p:ext uri="{BB962C8B-B14F-4D97-AF65-F5344CB8AC3E}">
+        <p14:creationId xmlns:p14="http://schemas.microsoft.com/office/powerpoint/2010/main" val="3677744756"/>
       </p:ext>
     </p:extLst>
   </p:cSld>
@@ -600,7 +1372,6 @@
               <a:rPr lang="en-US" dirty="0"/>
               <a:t>Los dos portafolios y sus plazos. La propuesta atiende el pilar de liquidez.</a:t>
             </a:r>
-            <a:endParaRPr lang="en-US" dirty="0"/>
           </a:p>
         </p:txBody>
       </p:sp>
@@ -688,7 +1459,6 @@
               <a:rPr lang="en-US" dirty="0"/>
               <a:t>Definición de la variable y las tres dimensiones de análisis.</a:t>
             </a:r>
-            <a:endParaRPr lang="en-US" dirty="0"/>
           </a:p>
         </p:txBody>
       </p:sp>
@@ -776,7 +1546,6 @@
               <a:rPr lang="en-US" dirty="0"/>
               <a:t>Los tres hallazgos sobre la serie 2010–2026.</a:t>
             </a:r>
-            <a:endParaRPr lang="en-US" dirty="0"/>
           </a:p>
         </p:txBody>
       </p:sp>
@@ -864,7 +1633,6 @@
               <a:rPr lang="en-US" dirty="0"/>
               <a:t>El flujo del día de vencimiento subestima el requerimiento del período.</a:t>
             </a:r>
-            <a:endParaRPr lang="en-US" dirty="0"/>
           </a:p>
         </p:txBody>
       </p:sp>
@@ -952,7 +1720,6 @@
               <a:rPr lang="en-US" dirty="0"/>
               <a:t>Definición del indicador y por qué se mide desde el origen.</a:t>
             </a:r>
-            <a:endParaRPr lang="en-US" dirty="0"/>
           </a:p>
         </p:txBody>
       </p:sp>
@@ -1040,7 +1807,6 @@
               <a:rPr lang="en-US" dirty="0"/>
               <a:t>Ficha del entregable: qué es, qué se modela, cómo y para qué.</a:t>
             </a:r>
-            <a:endParaRPr lang="en-US" dirty="0"/>
           </a:p>
         </p:txBody>
       </p:sp>
@@ -1128,7 +1894,6 @@
               <a:rPr lang="en-US" dirty="0"/>
               <a:t>Representación del formato de salida, no un pronóstico.</a:t>
             </a:r>
-            <a:endParaRPr lang="en-US" dirty="0"/>
           </a:p>
         </p:txBody>
       </p:sp>
@@ -1216,7 +1981,6 @@
               <a:rPr lang="en-US" dirty="0"/>
               <a:t>Cierre: relevancia y la invitación a trabajarlo en conjunto.</a:t>
             </a:r>
-            <a:endParaRPr lang="en-US" dirty="0"/>
           </a:p>
         </p:txBody>
       </p:sp>
@@ -1289,6 +2053,11 @@
 <file path=ppt/slideMasters/slideMaster1.xml><?xml version="1.0" encoding="utf-8"?>
 <p:sldMaster xmlns:a="http://schemas.openxmlformats.org/drawingml/2006/main" xmlns:r="http://schemas.openxmlformats.org/officeDocument/2006/relationships" xmlns:p="http://schemas.openxmlformats.org/presentationml/2006/main">
   <p:cSld>
+    <p:bg>
+      <p:bgRef idx="1001">
+        <a:schemeClr val="bg1"/>
+      </p:bgRef>
+    </p:bg>
     <p:spTree>
       <p:nvGrpSpPr>
         <p:cNvPr id="1" name=""/>
@@ -1565,10 +2334,16 @@
 
 <file path=ppt/slides/slide1.xml><?xml version="1.0" encoding="utf-8"?>
 <p:sld xmlns:a="http://schemas.openxmlformats.org/drawingml/2006/main" xmlns:r="http://schemas.openxmlformats.org/officeDocument/2006/relationships" xmlns:p="http://schemas.openxmlformats.org/presentationml/2006/main">
-  <p:cSld name="Slide 1">
+  <p:cSld>
     <p:spTree>
       <p:nvGrpSpPr>
-        <p:cNvPr id="1" name=""/>
+        <p:cNvPr id="1" name="">
+          <a:extLst>
+            <a:ext uri="{FF2B5EF4-FFF2-40B4-BE49-F238E27FC236}">
+              <a16:creationId xmlns:a16="http://schemas.microsoft.com/office/drawing/2014/main" id="{8C9EDB42-32F1-862E-CA67-5D9842FAECCA}"/>
+            </a:ext>
+          </a:extLst>
+        </p:cNvPr>
         <p:cNvGrpSpPr/>
         <p:nvPr/>
       </p:nvGrpSpPr>
@@ -1582,13 +2357,19 @@
       </p:grpSpPr>
       <p:sp>
         <p:nvSpPr>
-          <p:cNvPr id="2" name="Text 0"/>
+          <p:cNvPr id="2" name="Text 0">
+            <a:extLst>
+              <a:ext uri="{FF2B5EF4-FFF2-40B4-BE49-F238E27FC236}">
+                <a16:creationId xmlns:a16="http://schemas.microsoft.com/office/drawing/2014/main" id="{868E4EA8-20AD-09A3-10E7-962F2E49B15E}"/>
+              </a:ext>
+            </a:extLst>
+          </p:cNvPr>
           <p:cNvSpPr txBox="1"/>
           <p:nvPr/>
         </p:nvSpPr>
         <p:spPr>
           <a:xfrm>
-            <a:off x="1097280" y="2606040"/>
+            <a:off x="1028268" y="2148840"/>
             <a:ext cx="9994392" cy="1280160"/>
           </a:xfrm>
           <a:prstGeom prst="rect">
@@ -1601,7 +2382,7 @@
           <a:bodyPr wrap="square" lIns="0" tIns="0" rIns="0" bIns="0" rtlCol="0" anchor="ctr"/>
           <a:lstStyle/>
           <a:p>
-            <a:pPr algn="ctr" indent="0" marL="0">
+            <a:pPr marL="0" indent="0" algn="ctr">
               <a:lnSpc>
                 <a:spcPts val="3800"/>
               </a:lnSpc>
@@ -1621,7 +2402,7 @@
             <a:endParaRPr lang="en-US" sz="2800" dirty="0"/>
           </a:p>
           <a:p>
-            <a:pPr algn="ctr" indent="0" marL="0">
+            <a:pPr marL="0" indent="0" algn="ctr">
               <a:lnSpc>
                 <a:spcPts val="3800"/>
               </a:lnSpc>
@@ -1644,13 +2425,19 @@
       </p:sp>
       <p:sp>
         <p:nvSpPr>
-          <p:cNvPr id="3" name="Shape 1"/>
+          <p:cNvPr id="3" name="Shape 1">
+            <a:extLst>
+              <a:ext uri="{FF2B5EF4-FFF2-40B4-BE49-F238E27FC236}">
+                <a16:creationId xmlns:a16="http://schemas.microsoft.com/office/drawing/2014/main" id="{66BB9AA8-2211-A47F-FF67-F50DF03A296A}"/>
+              </a:ext>
+            </a:extLst>
+          </p:cNvPr>
           <p:cNvSpPr/>
           <p:nvPr/>
         </p:nvSpPr>
         <p:spPr>
           <a:xfrm>
-            <a:off x="5687568" y="4041648"/>
+            <a:off x="5618556" y="3584448"/>
             <a:ext cx="822960" cy="45720"/>
           </a:xfrm>
           <a:prstGeom prst="rect">
@@ -1661,16 +2448,29 @@
           </a:solidFill>
           <a:ln/>
         </p:spPr>
-      </p:sp>
-      <p:sp>
-        <p:nvSpPr>
-          <p:cNvPr id="4" name="Text 2"/>
+        <p:txBody>
+          <a:bodyPr/>
+          <a:lstStyle/>
+          <a:p>
+            <a:endParaRPr lang="es-PE"/>
+          </a:p>
+        </p:txBody>
+      </p:sp>
+      <p:sp>
+        <p:nvSpPr>
+          <p:cNvPr id="4" name="Text 2">
+            <a:extLst>
+              <a:ext uri="{FF2B5EF4-FFF2-40B4-BE49-F238E27FC236}">
+                <a16:creationId xmlns:a16="http://schemas.microsoft.com/office/drawing/2014/main" id="{6D77161A-20EB-9D1D-03D9-85A385975AC7}"/>
+              </a:ext>
+            </a:extLst>
+          </p:cNvPr>
           <p:cNvSpPr txBox="1"/>
           <p:nvPr/>
         </p:nvSpPr>
         <p:spPr>
           <a:xfrm>
-            <a:off x="1737360" y="4297680"/>
+            <a:off x="1668348" y="3840480"/>
             <a:ext cx="8714232" cy="365760"/>
           </a:xfrm>
           <a:prstGeom prst="rect">
@@ -1683,7 +2483,7 @@
           <a:bodyPr wrap="square" lIns="0" tIns="0" rIns="0" bIns="0" rtlCol="0" anchor="ctr"/>
           <a:lstStyle/>
           <a:p>
-            <a:pPr algn="ctr" indent="0" marL="0">
+            <a:pPr marL="0" indent="0" algn="ctr">
               <a:buNone/>
             </a:pPr>
             <a:r>
@@ -1701,16 +2501,118 @@
           </a:p>
         </p:txBody>
       </p:sp>
-      <p:sp>
-        <p:nvSpPr>
-          <p:cNvPr id="5" name="Text 3"/>
+      <p:pic>
+        <p:nvPicPr>
+          <p:cNvPr id="7" name="Image 0" descr="kori_media/image2.jpeg">
+            <a:extLst>
+              <a:ext uri="{FF2B5EF4-FFF2-40B4-BE49-F238E27FC236}">
+                <a16:creationId xmlns:a16="http://schemas.microsoft.com/office/drawing/2014/main" id="{D8260439-8BEF-41C4-BED1-54136235A757}"/>
+              </a:ext>
+            </a:extLst>
+          </p:cNvPr>
+          <p:cNvPicPr>
+            <a:picLocks noChangeAspect="1"/>
+          </p:cNvPicPr>
+          <p:nvPr/>
+        </p:nvPicPr>
+        <p:blipFill>
+          <a:blip r:embed="rId3"/>
+          <a:stretch>
+            <a:fillRect/>
+          </a:stretch>
+        </p:blipFill>
+        <p:spPr>
+          <a:xfrm>
+            <a:off x="0" y="0"/>
+            <a:ext cx="12188952" cy="1335024"/>
+          </a:xfrm>
+          <a:prstGeom prst="rect">
+            <a:avLst/>
+          </a:prstGeom>
+        </p:spPr>
+      </p:pic>
+      <p:pic>
+        <p:nvPicPr>
+          <p:cNvPr id="9" name="Image 1" descr="kori_media/image3.png">
+            <a:extLst>
+              <a:ext uri="{FF2B5EF4-FFF2-40B4-BE49-F238E27FC236}">
+                <a16:creationId xmlns:a16="http://schemas.microsoft.com/office/drawing/2014/main" id="{217E371E-DBF5-CF00-375F-84400CA68CA6}"/>
+              </a:ext>
+            </a:extLst>
+          </p:cNvPr>
+          <p:cNvPicPr>
+            <a:picLocks noChangeAspect="1"/>
+          </p:cNvPicPr>
+          <p:nvPr/>
+        </p:nvPicPr>
+        <p:blipFill>
+          <a:blip r:embed="rId4"/>
+          <a:stretch>
+            <a:fillRect/>
+          </a:stretch>
+        </p:blipFill>
+        <p:spPr>
+          <a:xfrm>
+            <a:off x="0" y="5559552"/>
+            <a:ext cx="12188952" cy="1298448"/>
+          </a:xfrm>
+          <a:prstGeom prst="rect">
+            <a:avLst/>
+          </a:prstGeom>
+        </p:spPr>
+      </p:pic>
+    </p:spTree>
+    <p:extLst>
+      <p:ext uri="{BB962C8B-B14F-4D97-AF65-F5344CB8AC3E}">
+        <p14:creationId xmlns:p14="http://schemas.microsoft.com/office/powerpoint/2010/main" val="3111203804"/>
+      </p:ext>
+    </p:extLst>
+  </p:cSld>
+  <p:clrMapOvr>
+    <a:masterClrMapping/>
+  </p:clrMapOvr>
+</p:sld>
+</file>
+
+<file path=ppt/slides/slide10.xml><?xml version="1.0" encoding="utf-8"?>
+<p:sld xmlns:a="http://schemas.openxmlformats.org/drawingml/2006/main" xmlns:r="http://schemas.openxmlformats.org/officeDocument/2006/relationships" xmlns:p="http://schemas.openxmlformats.org/presentationml/2006/main">
+  <p:cSld>
+    <p:spTree>
+      <p:nvGrpSpPr>
+        <p:cNvPr id="1" name="">
+          <a:extLst>
+            <a:ext uri="{FF2B5EF4-FFF2-40B4-BE49-F238E27FC236}">
+              <a16:creationId xmlns:a16="http://schemas.microsoft.com/office/drawing/2014/main" id="{4736ACE3-4C60-13A0-F6CC-7E8701ED4A69}"/>
+            </a:ext>
+          </a:extLst>
+        </p:cNvPr>
+        <p:cNvGrpSpPr/>
+        <p:nvPr/>
+      </p:nvGrpSpPr>
+      <p:grpSpPr>
+        <a:xfrm>
+          <a:off x="0" y="0"/>
+          <a:ext cx="0" cy="0"/>
+          <a:chOff x="0" y="0"/>
+          <a:chExt cx="0" cy="0"/>
+        </a:xfrm>
+      </p:grpSpPr>
+      <p:sp>
+        <p:nvSpPr>
+          <p:cNvPr id="2" name="Text 0">
+            <a:extLst>
+              <a:ext uri="{FF2B5EF4-FFF2-40B4-BE49-F238E27FC236}">
+                <a16:creationId xmlns:a16="http://schemas.microsoft.com/office/drawing/2014/main" id="{74A06A31-DD4D-8376-5AC8-02B5FC4FAD58}"/>
+              </a:ext>
+            </a:extLst>
+          </p:cNvPr>
           <p:cNvSpPr txBox="1"/>
           <p:nvPr/>
         </p:nvSpPr>
         <p:spPr>
           <a:xfrm>
-            <a:off x="1737360" y="4892040"/>
-            <a:ext cx="8714232" cy="731520"/>
+            <a:off x="1028268" y="2148840"/>
+            <a:ext cx="9994392" cy="1280160"/>
           </a:xfrm>
           <a:prstGeom prst="rect">
             <a:avLst/>
@@ -1722,44 +2624,565 @@
           <a:bodyPr wrap="square" lIns="0" tIns="0" rIns="0" bIns="0" rtlCol="0" anchor="ctr"/>
           <a:lstStyle/>
           <a:p>
-            <a:pPr algn="ctr" indent="0" marL="0">
+            <a:pPr marL="0" indent="0" algn="ctr">
               <a:lnSpc>
-                <a:spcPts val="2200"/>
+                <a:spcPts val="3800"/>
               </a:lnSpc>
               <a:buNone/>
             </a:pPr>
             <a:r>
-              <a:rPr lang="en-US" sz="1600" dirty="0">
-                <a:solidFill>
-                  <a:srgbClr val="767676"/>
+              <a:rPr lang="en-US" sz="2800" b="1" dirty="0">
+                <a:solidFill>
+                  <a:srgbClr val="073269"/>
                 </a:solidFill>
                 <a:latin typeface="Calibri" pitchFamily="34" charset="0"/>
                 <a:ea typeface="Calibri" pitchFamily="34" charset="-122"/>
                 <a:cs typeface="Calibri" pitchFamily="34" charset="-120"/>
               </a:rPr>
-              <a:t>Presentación al Departamento de Operaciones Monetarias</a:t>
-            </a:r>
-            <a:endParaRPr lang="en-US" sz="1600" dirty="0"/>
-          </a:p>
-          <a:p>
-            <a:pPr algn="ctr" indent="0" marL="0">
+              <a:t>SISTEMA DE ANÁLISIS Y ESTIMACIÓN</a:t>
+            </a:r>
+            <a:endParaRPr lang="en-US" sz="2800" dirty="0"/>
+          </a:p>
+          <a:p>
+            <a:pPr marL="0" indent="0" algn="ctr">
               <a:lnSpc>
-                <a:spcPts val="2200"/>
+                <a:spcPts val="3800"/>
               </a:lnSpc>
               <a:buNone/>
             </a:pPr>
             <a:r>
-              <a:rPr lang="en-US" sz="1600" dirty="0">
-                <a:solidFill>
-                  <a:srgbClr val="767676"/>
+              <a:rPr lang="en-US" sz="2800" b="1" dirty="0">
+                <a:solidFill>
+                  <a:srgbClr val="073269"/>
                 </a:solidFill>
                 <a:latin typeface="Calibri" pitchFamily="34" charset="0"/>
                 <a:ea typeface="Calibri" pitchFamily="34" charset="-122"/>
                 <a:cs typeface="Calibri" pitchFamily="34" charset="-120"/>
               </a:rPr>
-              <a:t>Agosto de 2026</a:t>
-            </a:r>
-            <a:endParaRPr lang="en-US" sz="1600" dirty="0"/>
+              <a:t>DE REQUERIMIENTOS DE LIQUIDEZ</a:t>
+            </a:r>
+            <a:endParaRPr lang="en-US" sz="2800" dirty="0"/>
+          </a:p>
+        </p:txBody>
+      </p:sp>
+      <p:sp>
+        <p:nvSpPr>
+          <p:cNvPr id="3" name="Shape 1">
+            <a:extLst>
+              <a:ext uri="{FF2B5EF4-FFF2-40B4-BE49-F238E27FC236}">
+                <a16:creationId xmlns:a16="http://schemas.microsoft.com/office/drawing/2014/main" id="{FE655D9C-E47B-1980-036C-301DDBBF2BC7}"/>
+              </a:ext>
+            </a:extLst>
+          </p:cNvPr>
+          <p:cNvSpPr/>
+          <p:nvPr/>
+        </p:nvSpPr>
+        <p:spPr>
+          <a:xfrm>
+            <a:off x="5618556" y="3584448"/>
+            <a:ext cx="822960" cy="45720"/>
+          </a:xfrm>
+          <a:prstGeom prst="rect">
+            <a:avLst/>
+          </a:prstGeom>
+          <a:solidFill>
+            <a:srgbClr val="C8A24B"/>
+          </a:solidFill>
+          <a:ln/>
+        </p:spPr>
+        <p:txBody>
+          <a:bodyPr/>
+          <a:lstStyle/>
+          <a:p>
+            <a:endParaRPr lang="es-PE"/>
+          </a:p>
+        </p:txBody>
+      </p:sp>
+      <p:sp>
+        <p:nvSpPr>
+          <p:cNvPr id="4" name="Text 2">
+            <a:extLst>
+              <a:ext uri="{FF2B5EF4-FFF2-40B4-BE49-F238E27FC236}">
+                <a16:creationId xmlns:a16="http://schemas.microsoft.com/office/drawing/2014/main" id="{7F340F98-1DED-66C3-17AF-545BCABCEA8C}"/>
+              </a:ext>
+            </a:extLst>
+          </p:cNvPr>
+          <p:cNvSpPr txBox="1"/>
+          <p:nvPr/>
+        </p:nvSpPr>
+        <p:spPr>
+          <a:xfrm>
+            <a:off x="1668348" y="3840480"/>
+            <a:ext cx="8714232" cy="365760"/>
+          </a:xfrm>
+          <a:prstGeom prst="rect">
+            <a:avLst/>
+          </a:prstGeom>
+          <a:noFill/>
+          <a:ln/>
+        </p:spPr>
+        <p:txBody>
+          <a:bodyPr wrap="square" lIns="0" tIns="0" rIns="0" bIns="0" rtlCol="0" anchor="ctr"/>
+          <a:lstStyle/>
+          <a:p>
+            <a:pPr marL="0" indent="0" algn="ctr">
+              <a:buNone/>
+            </a:pPr>
+            <a:r>
+              <a:rPr lang="en-US" sz="1800" dirty="0">
+                <a:solidFill>
+                  <a:srgbClr val="002060"/>
+                </a:solidFill>
+                <a:latin typeface="Calibri" pitchFamily="34" charset="0"/>
+                <a:ea typeface="Calibri" pitchFamily="34" charset="-122"/>
+                <a:cs typeface="Calibri" pitchFamily="34" charset="-120"/>
+              </a:rPr>
+              <a:t>Dinámica de los depósitos y retiros en moneda extranjera</a:t>
+            </a:r>
+            <a:endParaRPr lang="en-US" sz="1800" dirty="0"/>
+          </a:p>
+        </p:txBody>
+      </p:sp>
+      <p:pic>
+        <p:nvPicPr>
+          <p:cNvPr id="7" name="Image 0" descr="kori_media/image2.jpeg">
+            <a:extLst>
+              <a:ext uri="{FF2B5EF4-FFF2-40B4-BE49-F238E27FC236}">
+                <a16:creationId xmlns:a16="http://schemas.microsoft.com/office/drawing/2014/main" id="{4C3BACA2-001A-9891-8FDB-900EE318ECBB}"/>
+              </a:ext>
+            </a:extLst>
+          </p:cNvPr>
+          <p:cNvPicPr>
+            <a:picLocks noChangeAspect="1"/>
+          </p:cNvPicPr>
+          <p:nvPr/>
+        </p:nvPicPr>
+        <p:blipFill>
+          <a:blip r:embed="rId3"/>
+          <a:stretch>
+            <a:fillRect/>
+          </a:stretch>
+        </p:blipFill>
+        <p:spPr>
+          <a:xfrm>
+            <a:off x="0" y="0"/>
+            <a:ext cx="12188952" cy="1335024"/>
+          </a:xfrm>
+          <a:prstGeom prst="rect">
+            <a:avLst/>
+          </a:prstGeom>
+        </p:spPr>
+      </p:pic>
+      <p:pic>
+        <p:nvPicPr>
+          <p:cNvPr id="9" name="Image 1" descr="kori_media/image3.png">
+            <a:extLst>
+              <a:ext uri="{FF2B5EF4-FFF2-40B4-BE49-F238E27FC236}">
+                <a16:creationId xmlns:a16="http://schemas.microsoft.com/office/drawing/2014/main" id="{33FF89DF-19FF-6689-E6E8-4D93F8B5AD1F}"/>
+              </a:ext>
+            </a:extLst>
+          </p:cNvPr>
+          <p:cNvPicPr>
+            <a:picLocks noChangeAspect="1"/>
+          </p:cNvPicPr>
+          <p:nvPr/>
+        </p:nvPicPr>
+        <p:blipFill>
+          <a:blip r:embed="rId4"/>
+          <a:stretch>
+            <a:fillRect/>
+          </a:stretch>
+        </p:blipFill>
+        <p:spPr>
+          <a:xfrm>
+            <a:off x="0" y="5559552"/>
+            <a:ext cx="12188952" cy="1298448"/>
+          </a:xfrm>
+          <a:prstGeom prst="rect">
+            <a:avLst/>
+          </a:prstGeom>
+        </p:spPr>
+      </p:pic>
+    </p:spTree>
+    <p:extLst>
+      <p:ext uri="{BB962C8B-B14F-4D97-AF65-F5344CB8AC3E}">
+        <p14:creationId xmlns:p14="http://schemas.microsoft.com/office/powerpoint/2010/main" val="4243702655"/>
+      </p:ext>
+    </p:extLst>
+  </p:cSld>
+  <p:clrMapOvr>
+    <a:masterClrMapping/>
+  </p:clrMapOvr>
+</p:sld>
+</file>
+
+<file path=ppt/slides/slide11.xml><?xml version="1.0" encoding="utf-8"?>
+<p:sld xmlns:a="http://schemas.openxmlformats.org/drawingml/2006/main" xmlns:p="http://schemas.openxmlformats.org/presentationml/2006/main" xmlns:r="http://schemas.openxmlformats.org/officeDocument/2006/relationships">
+  <p:cSld>
+    <p:spTree>
+      <p:nvGrpSpPr>
+        <p:cNvPr id="1" name=""/>
+        <p:cNvGrpSpPr/>
+        <p:nvPr/>
+      </p:nvGrpSpPr>
+      <p:grpSpPr/>
+      <p:sp>
+        <p:nvSpPr>
+          <p:cNvPr id="2" name="TextBox 1"/>
+          <p:cNvSpPr txBox="1"/>
+          <p:nvPr/>
+        </p:nvSpPr>
+        <p:spPr>
+          <a:xfrm>
+            <a:off x="886968" y="521207"/>
+            <a:ext cx="10405872" cy="640080"/>
+          </a:xfrm>
+          <a:prstGeom prst="rect">
+            <a:avLst/>
+          </a:prstGeom>
+          <a:noFill/>
+        </p:spPr>
+        <p:txBody>
+          <a:bodyPr wrap="square" lIns="0" rIns="0" tIns="0" bIns="0" anchor="t">
+            <a:spAutoFit/>
+          </a:bodyPr>
+          <a:lstStyle/>
+          <a:p>
+            <a:pPr algn="l"/>
+            <a:r>
+              <a:rPr sz="2800" b="1" i="0">
+                <a:solidFill>
+                  <a:srgbClr val="073269"/>
+                </a:solidFill>
+                <a:latin typeface="Calibri"/>
+              </a:rPr>
+              <a:t>III. Hallazgos: distribución dentro del mes</a:t>
+            </a:r>
+          </a:p>
+        </p:txBody>
+      </p:sp>
+      <p:sp>
+        <p:nvSpPr>
+          <p:cNvPr id="3" name="Rectangle 2"/>
+          <p:cNvSpPr/>
+          <p:nvPr/>
+        </p:nvSpPr>
+        <p:spPr>
+          <a:xfrm>
+            <a:off x="886968" y="1307592"/>
+            <a:ext cx="822960" cy="45720"/>
+          </a:xfrm>
+          <a:prstGeom prst="rect">
+            <a:avLst/>
+          </a:prstGeom>
+          <a:solidFill>
+            <a:srgbClr val="C8A24B"/>
+          </a:solidFill>
+          <a:ln>
+            <a:noFill/>
+          </a:ln>
+          <a:effectLst/>
+        </p:spPr>
+        <p:style>
+          <a:lnRef idx="1">
+            <a:schemeClr val="accent1"/>
+          </a:lnRef>
+          <a:fillRef idx="3">
+            <a:schemeClr val="accent1"/>
+          </a:fillRef>
+          <a:effectRef idx="2">
+            <a:schemeClr val="accent1"/>
+          </a:effectRef>
+          <a:fontRef idx="minor">
+            <a:schemeClr val="lt1"/>
+          </a:fontRef>
+        </p:style>
+        <p:txBody>
+          <a:bodyPr rtlCol="0" anchor="ctr"/>
+          <a:lstStyle/>
+          <a:p>
+            <a:pPr algn="ctr"/>
+          </a:p>
+        </p:txBody>
+      </p:sp>
+      <p:sp>
+        <p:nvSpPr>
+          <p:cNvPr id="4" name="TextBox 3"/>
+          <p:cNvSpPr txBox="1"/>
+          <p:nvPr/>
+        </p:nvSpPr>
+        <p:spPr>
+          <a:xfrm>
+            <a:off x="886968" y="1783080"/>
+            <a:ext cx="10405872" cy="1280160"/>
+          </a:xfrm>
+          <a:prstGeom prst="rect">
+            <a:avLst/>
+          </a:prstGeom>
+          <a:noFill/>
+        </p:spPr>
+        <p:txBody>
+          <a:bodyPr wrap="square" lIns="0" rIns="0" tIns="0" bIns="0" anchor="t">
+            <a:spAutoFit/>
+          </a:bodyPr>
+          <a:lstStyle/>
+          <a:p>
+            <a:pPr algn="just">
+              <a:lnSpc>
+                <a:spcPts val="2400"/>
+              </a:lnSpc>
+            </a:pPr>
+            <a:r>
+              <a:rPr sz="1600" b="0" i="0">
+                <a:solidFill>
+                  <a:srgbClr val="002060"/>
+                </a:solidFill>
+                <a:latin typeface="Calibri"/>
+              </a:rPr>
+              <a:t>La salida no se distribuye de manera uniforme a lo largo del mes. Los depósitos se mantienen estables en torno al 4 % diario, mientras que los retiros se concentran hacia el cierre: el último día hábil concentra el 10,3 % de los retiros del mes, frente al 5,0 % de los depósitos.</a:t>
+            </a:r>
+          </a:p>
+        </p:txBody>
+      </p:sp>
+      <p:graphicFrame>
+        <p:nvGraphicFramePr>
+          <p:cNvPr id="5" name="Chart 4"/>
+          <p:cNvGraphicFramePr>
+            <a:graphicFrameLocks noGrp="1"/>
+          </p:cNvGraphicFramePr>
+          <p:nvPr/>
+        </p:nvGraphicFramePr>
+        <p:xfrm>
+          <a:off x="886968" y="3246120"/>
+          <a:ext cx="10405872" cy="2606040"/>
+        </p:xfrm>
+        <a:graphic>
+          <a:graphicData uri="http://schemas.openxmlformats.org/drawingml/2006/chart">
+            <c:chart xmlns:c="http://schemas.openxmlformats.org/drawingml/2006/chart" r:id="rId2"/>
+          </a:graphicData>
+        </a:graphic>
+      </p:graphicFrame>
+      <p:sp>
+        <p:nvSpPr>
+          <p:cNvPr id="6" name="TextBox 5"/>
+          <p:cNvSpPr txBox="1"/>
+          <p:nvPr/>
+        </p:nvSpPr>
+        <p:spPr>
+          <a:xfrm>
+            <a:off x="886968" y="5989320"/>
+            <a:ext cx="10405872" cy="274320"/>
+          </a:xfrm>
+          <a:prstGeom prst="rect">
+            <a:avLst/>
+          </a:prstGeom>
+          <a:noFill/>
+        </p:spPr>
+        <p:txBody>
+          <a:bodyPr wrap="square" lIns="0" rIns="0" tIns="0" bIns="0" anchor="t">
+            <a:spAutoFit/>
+          </a:bodyPr>
+          <a:lstStyle/>
+          <a:p>
+            <a:pPr algn="l"/>
+            <a:r>
+              <a:rPr sz="1100" b="0" i="1">
+                <a:solidFill>
+                  <a:srgbClr val="767676"/>
+                </a:solidFill>
+                <a:latin typeface="Calibri"/>
+              </a:rPr>
+              <a:t>Porcentaje del total mensual de retiros y de depósitos que ocurre en cada día hábil, según días restantes hasta el cierre. Promedio de los meses de cierre trimestral, 2010–2026.</a:t>
+            </a:r>
+          </a:p>
+        </p:txBody>
+      </p:sp>
+    </p:spTree>
+  </p:cSld>
+  <p:clrMapOvr>
+    <a:masterClrMapping/>
+  </p:clrMapOvr>
+</p:sld>
+</file>
+
+<file path=ppt/slides/slide12.xml><?xml version="1.0" encoding="utf-8"?>
+<p:sld xmlns:a="http://schemas.openxmlformats.org/drawingml/2006/main" xmlns:p="http://schemas.openxmlformats.org/presentationml/2006/main" xmlns:r="http://schemas.openxmlformats.org/officeDocument/2006/relationships">
+  <p:cSld>
+    <p:spTree>
+      <p:nvGrpSpPr>
+        <p:cNvPr id="1" name=""/>
+        <p:cNvGrpSpPr/>
+        <p:nvPr/>
+      </p:nvGrpSpPr>
+      <p:grpSpPr/>
+      <p:sp>
+        <p:nvSpPr>
+          <p:cNvPr id="2" name="TextBox 1"/>
+          <p:cNvSpPr txBox="1"/>
+          <p:nvPr/>
+        </p:nvSpPr>
+        <p:spPr>
+          <a:xfrm>
+            <a:off x="886968" y="521207"/>
+            <a:ext cx="10405872" cy="640080"/>
+          </a:xfrm>
+          <a:prstGeom prst="rect">
+            <a:avLst/>
+          </a:prstGeom>
+          <a:noFill/>
+        </p:spPr>
+        <p:txBody>
+          <a:bodyPr wrap="square" lIns="0" rIns="0" tIns="0" bIns="0" anchor="t">
+            <a:spAutoFit/>
+          </a:bodyPr>
+          <a:lstStyle/>
+          <a:p>
+            <a:pPr algn="l"/>
+            <a:r>
+              <a:rPr sz="2800" b="1" i="0">
+                <a:solidFill>
+                  <a:srgbClr val="073269"/>
+                </a:solidFill>
+                <a:latin typeface="Calibri"/>
+              </a:rPr>
+              <a:t>III. Hallazgos: composición por entidad</a:t>
+            </a:r>
+          </a:p>
+        </p:txBody>
+      </p:sp>
+      <p:sp>
+        <p:nvSpPr>
+          <p:cNvPr id="3" name="Rectangle 2"/>
+          <p:cNvSpPr/>
+          <p:nvPr/>
+        </p:nvSpPr>
+        <p:spPr>
+          <a:xfrm>
+            <a:off x="886968" y="1307592"/>
+            <a:ext cx="822960" cy="45720"/>
+          </a:xfrm>
+          <a:prstGeom prst="rect">
+            <a:avLst/>
+          </a:prstGeom>
+          <a:solidFill>
+            <a:srgbClr val="C8A24B"/>
+          </a:solidFill>
+          <a:ln>
+            <a:noFill/>
+          </a:ln>
+          <a:effectLst/>
+        </p:spPr>
+        <p:style>
+          <a:lnRef idx="1">
+            <a:schemeClr val="accent1"/>
+          </a:lnRef>
+          <a:fillRef idx="3">
+            <a:schemeClr val="accent1"/>
+          </a:fillRef>
+          <a:effectRef idx="2">
+            <a:schemeClr val="accent1"/>
+          </a:effectRef>
+          <a:fontRef idx="minor">
+            <a:schemeClr val="lt1"/>
+          </a:fontRef>
+        </p:style>
+        <p:txBody>
+          <a:bodyPr rtlCol="0" anchor="ctr"/>
+          <a:lstStyle/>
+          <a:p>
+            <a:pPr algn="ctr"/>
+          </a:p>
+        </p:txBody>
+      </p:sp>
+      <p:sp>
+        <p:nvSpPr>
+          <p:cNvPr id="4" name="TextBox 3"/>
+          <p:cNvSpPr txBox="1"/>
+          <p:nvPr/>
+        </p:nvSpPr>
+        <p:spPr>
+          <a:xfrm>
+            <a:off x="886968" y="1783080"/>
+            <a:ext cx="10405872" cy="1280160"/>
+          </a:xfrm>
+          <a:prstGeom prst="rect">
+            <a:avLst/>
+          </a:prstGeom>
+          <a:noFill/>
+        </p:spPr>
+        <p:txBody>
+          <a:bodyPr wrap="square" lIns="0" rIns="0" tIns="0" bIns="0" anchor="t">
+            <a:spAutoFit/>
+          </a:bodyPr>
+          <a:lstStyle/>
+          <a:p>
+            <a:pPr algn="just">
+              <a:lnSpc>
+                <a:spcPts val="2400"/>
+              </a:lnSpc>
+            </a:pPr>
+            <a:r>
+              <a:rPr sz="1600" b="0" i="0">
+                <a:solidFill>
+                  <a:srgbClr val="002060"/>
+                </a:solidFill>
+                <a:latin typeface="Calibri"/>
+              </a:rPr>
+              <a:t>Una sola entidad concentra la mayor parte de la salida al cierre, en una proporción superior a la que explicaría su tamaño relativo. Su participación en los retiros del sistema durante la ventana de cierre pasó de un promedio de 40 % entre 2010 y 2017 a 65 % entre 2018 y 2025, con los tres últimos años completos en torno al 80 %.</a:t>
+            </a:r>
+          </a:p>
+        </p:txBody>
+      </p:sp>
+      <p:graphicFrame>
+        <p:nvGraphicFramePr>
+          <p:cNvPr id="5" name="Chart 4"/>
+          <p:cNvGraphicFramePr>
+            <a:graphicFrameLocks noGrp="1"/>
+          </p:cNvGraphicFramePr>
+          <p:nvPr/>
+        </p:nvGraphicFramePr>
+        <p:xfrm>
+          <a:off x="886968" y="3246120"/>
+          <a:ext cx="10405872" cy="2606040"/>
+        </p:xfrm>
+        <a:graphic>
+          <a:graphicData uri="http://schemas.openxmlformats.org/drawingml/2006/chart">
+            <c:chart xmlns:c="http://schemas.openxmlformats.org/drawingml/2006/chart" r:id="rId2"/>
+          </a:graphicData>
+        </a:graphic>
+      </p:graphicFrame>
+      <p:sp>
+        <p:nvSpPr>
+          <p:cNvPr id="6" name="TextBox 5"/>
+          <p:cNvSpPr txBox="1"/>
+          <p:nvPr/>
+        </p:nvSpPr>
+        <p:spPr>
+          <a:xfrm>
+            <a:off x="886968" y="5989320"/>
+            <a:ext cx="10405872" cy="274320"/>
+          </a:xfrm>
+          <a:prstGeom prst="rect">
+            <a:avLst/>
+          </a:prstGeom>
+          <a:noFill/>
+        </p:spPr>
+        <p:txBody>
+          <a:bodyPr wrap="square" lIns="0" rIns="0" tIns="0" bIns="0" anchor="t">
+            <a:spAutoFit/>
+          </a:bodyPr>
+          <a:lstStyle/>
+          <a:p>
+            <a:pPr algn="l"/>
+            <a:r>
+              <a:rPr sz="1100" b="0" i="1">
+                <a:solidFill>
+                  <a:srgbClr val="767676"/>
+                </a:solidFill>
+                <a:latin typeface="Calibri"/>
+              </a:rPr>
+              <a:t>Participación de la entidad de mayor peso en los retiros del sistema durante la ventana de cierre trimestral, promedio anual. Se excluye 2026 por tratarse de un año parcial.</a:t>
+            </a:r>
           </a:p>
         </p:txBody>
       </p:sp>
@@ -1809,7 +3232,7 @@
           <a:bodyPr wrap="square" lIns="0" tIns="0" rIns="0" bIns="0" rtlCol="0" anchor="ctr"/>
           <a:lstStyle/>
           <a:p>
-            <a:pPr indent="0" marL="0">
+            <a:pPr marL="0" indent="0">
               <a:buNone/>
             </a:pPr>
             <a:r>
@@ -1846,6 +3269,13 @@
           </a:solidFill>
           <a:ln/>
         </p:spPr>
+        <p:txBody>
+          <a:bodyPr/>
+          <a:lstStyle/>
+          <a:p>
+            <a:endParaRPr lang="es-PE"/>
+          </a:p>
+        </p:txBody>
       </p:sp>
       <p:sp>
         <p:nvSpPr>
@@ -1868,7 +3298,7 @@
           <a:bodyPr wrap="square" lIns="0" tIns="0" rIns="0" bIns="0" rtlCol="0" anchor="t"/>
           <a:lstStyle/>
           <a:p>
-            <a:pPr algn="just" indent="0" marL="0">
+            <a:pPr marL="0" indent="0" algn="just">
               <a:lnSpc>
                 <a:spcPts val="2400"/>
               </a:lnSpc>
@@ -1883,7 +3313,51 @@
                 <a:ea typeface="Calibri" pitchFamily="34" charset="-122"/>
                 <a:cs typeface="Calibri" pitchFamily="34" charset="-120"/>
               </a:rPr>
-              <a:t>Los ingresos netos del Sistema Financiero se depositan en dos portafolios de corto plazo, desde los cuales los recursos se asignan a distintos instrumentos y plazos de money market. La gestión de las Reservas Internacionales Netas se rige por tres pilares: seguridad, liquidez y retorno. La presente propuesta se orienta al segundo de ellos, en los tramos de corto plazo, y no busca prescribir la gestión de liquidez sino aportar una referencia del entorno de riesgo en el que se decide.</a:t>
+              <a:t>Los ingresos netos del Sistema Financiero se depositan en dos portafolios de corto plazo, desde los cuales los recursos se asignan a distintos instrumentos y plazos de </a:t>
+            </a:r>
+            <a:r>
+              <a:rPr lang="en-US" sz="1600" i="1" dirty="0">
+                <a:solidFill>
+                  <a:srgbClr val="002060"/>
+                </a:solidFill>
+                <a:latin typeface="Calibri" pitchFamily="34" charset="0"/>
+                <a:ea typeface="Calibri" pitchFamily="34" charset="-122"/>
+                <a:cs typeface="Calibri" pitchFamily="34" charset="-120"/>
+              </a:rPr>
+              <a:t>money market</a:t>
+            </a:r>
+            <a:r>
+              <a:rPr lang="en-US" sz="1600" dirty="0">
+                <a:solidFill>
+                  <a:srgbClr val="002060"/>
+                </a:solidFill>
+                <a:latin typeface="Calibri" pitchFamily="34" charset="0"/>
+                <a:ea typeface="Calibri" pitchFamily="34" charset="-122"/>
+                <a:cs typeface="Calibri" pitchFamily="34" charset="-120"/>
+              </a:rPr>
+              <a:t>. </a:t>
+            </a:r>
+            <a:r>
+              <a:rPr lang="en-US" sz="1600" dirty="0" err="1">
+                <a:solidFill>
+                  <a:srgbClr val="002060"/>
+                </a:solidFill>
+                <a:latin typeface="Calibri" pitchFamily="34" charset="0"/>
+                <a:ea typeface="Calibri" pitchFamily="34" charset="-122"/>
+                <a:cs typeface="Calibri" pitchFamily="34" charset="-120"/>
+              </a:rPr>
+              <a:t>Asímismo</a:t>
+            </a:r>
+            <a:r>
+              <a:rPr lang="en-US" sz="1600" dirty="0">
+                <a:solidFill>
+                  <a:srgbClr val="002060"/>
+                </a:solidFill>
+                <a:latin typeface="Calibri" pitchFamily="34" charset="0"/>
+                <a:ea typeface="Calibri" pitchFamily="34" charset="-122"/>
+                <a:cs typeface="Calibri" pitchFamily="34" charset="-120"/>
+              </a:rPr>
+              <a:t>, la gestión de las Reservas Internacionales Netas se rige por tres pilares: seguridad, liquidez y retorno. La presente propuesta se orienta al segundo de ellos, en los tramos de corto plazo, y no busca prescribir la gestión de liquidez sino aportar una referencia del entorno de riesgo en el que se decide.</a:t>
             </a:r>
             <a:endParaRPr lang="en-US" sz="1600" dirty="0"/>
           </a:p>
@@ -1913,6 +3387,13 @@
             <a:prstDash val="solid"/>
           </a:ln>
         </p:spPr>
+        <p:txBody>
+          <a:bodyPr/>
+          <a:lstStyle/>
+          <a:p>
+            <a:endParaRPr lang="es-PE"/>
+          </a:p>
+        </p:txBody>
       </p:sp>
       <p:sp>
         <p:nvSpPr>
@@ -1935,7 +3416,7 @@
           <a:bodyPr wrap="square" lIns="0" tIns="0" rIns="0" bIns="0" rtlCol="0" anchor="ctr"/>
           <a:lstStyle/>
           <a:p>
-            <a:pPr indent="0" marL="0">
+            <a:pPr marL="0" indent="0">
               <a:buNone/>
             </a:pPr>
             <a:r>
@@ -1974,7 +3455,7 @@
           <a:bodyPr wrap="square" lIns="0" tIns="0" rIns="0" bIns="0" rtlCol="0" anchor="ctr"/>
           <a:lstStyle/>
           <a:p>
-            <a:pPr indent="0" marL="0">
+            <a:pPr marL="0" indent="0">
               <a:buNone/>
             </a:pPr>
             <a:r>
@@ -2013,7 +3494,7 @@
           <a:bodyPr wrap="square" lIns="0" tIns="0" rIns="0" bIns="0" rtlCol="0" anchor="t"/>
           <a:lstStyle/>
           <a:p>
-            <a:pPr algn="just" indent="0" marL="0">
+            <a:pPr marL="0" indent="0" algn="just">
               <a:lnSpc>
                 <a:spcPts val="1800"/>
               </a:lnSpc>
@@ -2058,6 +3539,13 @@
             <a:prstDash val="solid"/>
           </a:ln>
         </p:spPr>
+        <p:txBody>
+          <a:bodyPr/>
+          <a:lstStyle/>
+          <a:p>
+            <a:endParaRPr lang="es-PE"/>
+          </a:p>
+        </p:txBody>
       </p:sp>
       <p:sp>
         <p:nvSpPr>
@@ -2080,7 +3568,7 @@
           <a:bodyPr wrap="square" lIns="0" tIns="0" rIns="0" bIns="0" rtlCol="0" anchor="ctr"/>
           <a:lstStyle/>
           <a:p>
-            <a:pPr indent="0" marL="0">
+            <a:pPr marL="0" indent="0">
               <a:buNone/>
             </a:pPr>
             <a:r>
@@ -2119,7 +3607,7 @@
           <a:bodyPr wrap="square" lIns="0" tIns="0" rIns="0" bIns="0" rtlCol="0" anchor="ctr"/>
           <a:lstStyle/>
           <a:p>
-            <a:pPr indent="0" marL="0">
+            <a:pPr marL="0" indent="0">
               <a:buNone/>
             </a:pPr>
             <a:r>
@@ -2158,7 +3646,7 @@
           <a:bodyPr wrap="square" lIns="0" tIns="0" rIns="0" bIns="0" rtlCol="0" anchor="t"/>
           <a:lstStyle/>
           <a:p>
-            <a:pPr algn="just" indent="0" marL="0">
+            <a:pPr marL="0" indent="0" algn="just">
               <a:lnSpc>
                 <a:spcPts val="1800"/>
               </a:lnSpc>
@@ -2173,7 +3661,51 @@
                 <a:ea typeface="Calibri" pitchFamily="34" charset="-122"/>
                 <a:cs typeface="Calibri" pitchFamily="34" charset="-120"/>
               </a:rPr>
-              <a:t>Cubre el resto del horizonte de corto plazo. Cada tramo se dimensiona contra la caída máxima acumulada de su propio plazo, que no puede disminuir al alargar el horizonte.</a:t>
+              <a:t>Cubre el resto del horizonte de corto plazo. Por </a:t>
+            </a:r>
+            <a:r>
+              <a:rPr lang="en-US" sz="1300" dirty="0" err="1">
+                <a:solidFill>
+                  <a:srgbClr val="002060"/>
+                </a:solidFill>
+                <a:latin typeface="Calibri" pitchFamily="34" charset="0"/>
+                <a:ea typeface="Calibri" pitchFamily="34" charset="-122"/>
+                <a:cs typeface="Calibri" pitchFamily="34" charset="-120"/>
+              </a:rPr>
+              <a:t>consiguiente</a:t>
+            </a:r>
+            <a:r>
+              <a:rPr lang="en-US" sz="1300" dirty="0">
+                <a:solidFill>
+                  <a:srgbClr val="002060"/>
+                </a:solidFill>
+                <a:latin typeface="Calibri" pitchFamily="34" charset="0"/>
+                <a:ea typeface="Calibri" pitchFamily="34" charset="-122"/>
+                <a:cs typeface="Calibri" pitchFamily="34" charset="-120"/>
+              </a:rPr>
+              <a:t>, </a:t>
+            </a:r>
+            <a:r>
+              <a:rPr lang="en-US" sz="1300" dirty="0" err="1">
+                <a:solidFill>
+                  <a:srgbClr val="002060"/>
+                </a:solidFill>
+                <a:latin typeface="Calibri" pitchFamily="34" charset="0"/>
+                <a:ea typeface="Calibri" pitchFamily="34" charset="-122"/>
+                <a:cs typeface="Calibri" pitchFamily="34" charset="-120"/>
+              </a:rPr>
+              <a:t>cada</a:t>
+            </a:r>
+            <a:r>
+              <a:rPr lang="en-US" sz="1300" dirty="0">
+                <a:solidFill>
+                  <a:srgbClr val="002060"/>
+                </a:solidFill>
+                <a:latin typeface="Calibri" pitchFamily="34" charset="0"/>
+                <a:ea typeface="Calibri" pitchFamily="34" charset="-122"/>
+                <a:cs typeface="Calibri" pitchFamily="34" charset="-120"/>
+              </a:rPr>
+              <a:t> tramo se dimensiona contra la caída máxima acumulada de su propio plazo, que no puede disminuir al alargar el horizonte.</a:t>
             </a:r>
             <a:endParaRPr lang="en-US" sz="1300" dirty="0"/>
           </a:p>
@@ -2225,7 +3757,7 @@
           <a:bodyPr wrap="square" lIns="0" tIns="0" rIns="0" bIns="0" rtlCol="0" anchor="ctr"/>
           <a:lstStyle/>
           <a:p>
-            <a:pPr indent="0" marL="0">
+            <a:pPr marL="0" indent="0">
               <a:buNone/>
             </a:pPr>
             <a:r>
@@ -2262,6 +3794,13 @@
           </a:solidFill>
           <a:ln/>
         </p:spPr>
+        <p:txBody>
+          <a:bodyPr/>
+          <a:lstStyle/>
+          <a:p>
+            <a:endParaRPr lang="es-PE"/>
+          </a:p>
+        </p:txBody>
       </p:sp>
       <p:sp>
         <p:nvSpPr>
@@ -2284,7 +3823,7 @@
           <a:bodyPr wrap="square" lIns="0" tIns="0" rIns="0" bIns="0" rtlCol="0" anchor="t"/>
           <a:lstStyle/>
           <a:p>
-            <a:pPr algn="just" indent="0" marL="0">
+            <a:pPr marL="0" indent="0" algn="just">
               <a:lnSpc>
                 <a:spcPts val="2400"/>
               </a:lnSpc>
@@ -2299,7 +3838,29 @@
                 <a:ea typeface="Calibri" pitchFamily="34" charset="-122"/>
                 <a:cs typeface="Calibri" pitchFamily="34" charset="-120"/>
               </a:rPr>
-              <a:t>El análisis modela el flujo neto diario de depósitos y retiros del conjunto del sistema bancario frente a sus cuentas en moneda extranjera en el Banco Central, correspondiente a las operaciones de transferencia al exterior. La variable de interés es la salida neta, definida como retiros menos depósitos, dado que los depósitos constituyen entradas que compensan dicha salida. El período de análisis comprende los años 2010 a 2026.</a:t>
+              <a:t>El análisis modela el flujo neto diario de depósitos y retiros del conjunto del sistema bancario frente a sus cuentas en moneda extranjera en el Banco Central, correspondiente a las operaciones de transferencia al exterior. De </a:t>
+            </a:r>
+            <a:r>
+              <a:rPr lang="en-US" sz="1600" dirty="0" err="1">
+                <a:solidFill>
+                  <a:srgbClr val="002060"/>
+                </a:solidFill>
+                <a:latin typeface="Calibri" pitchFamily="34" charset="0"/>
+                <a:ea typeface="Calibri" pitchFamily="34" charset="-122"/>
+                <a:cs typeface="Calibri" pitchFamily="34" charset="-120"/>
+              </a:rPr>
+              <a:t>este</a:t>
+            </a:r>
+            <a:r>
+              <a:rPr lang="en-US" sz="1600" dirty="0">
+                <a:solidFill>
+                  <a:srgbClr val="002060"/>
+                </a:solidFill>
+                <a:latin typeface="Calibri" pitchFamily="34" charset="0"/>
+                <a:ea typeface="Calibri" pitchFamily="34" charset="-122"/>
+                <a:cs typeface="Calibri" pitchFamily="34" charset="-120"/>
+              </a:rPr>
+              <a:t> modo, la variable de interés es la salida neta, definida como retiros menos depósitos, dado que los depósitos constituyen entradas que compensan dicha salida. El período de análisis comprende los años 2010 a 2026.</a:t>
             </a:r>
             <a:endParaRPr lang="en-US" sz="1600" dirty="0"/>
           </a:p>
@@ -2326,7 +3887,7 @@
           <a:bodyPr wrap="square" lIns="0" tIns="0" rIns="0" bIns="0" rtlCol="0" anchor="t"/>
           <a:lstStyle/>
           <a:p>
-            <a:pPr algn="just" indent="0" marL="0">
+            <a:pPr marL="0" indent="0" algn="just">
               <a:lnSpc>
                 <a:spcPts val="2400"/>
               </a:lnSpc>
@@ -2371,6 +3932,13 @@
             <a:prstDash val="solid"/>
           </a:ln>
         </p:spPr>
+        <p:txBody>
+          <a:bodyPr/>
+          <a:lstStyle/>
+          <a:p>
+            <a:endParaRPr lang="es-PE"/>
+          </a:p>
+        </p:txBody>
       </p:sp>
       <p:sp>
         <p:nvSpPr>
@@ -2393,7 +3961,7 @@
           <a:bodyPr wrap="square" lIns="0" tIns="0" rIns="0" bIns="0" rtlCol="0" anchor="ctr"/>
           <a:lstStyle/>
           <a:p>
-            <a:pPr indent="0" marL="0">
+            <a:pPr marL="0" indent="0">
               <a:buNone/>
             </a:pPr>
             <a:r>
@@ -2432,7 +4000,7 @@
           <a:bodyPr wrap="square" lIns="0" tIns="0" rIns="0" bIns="0" rtlCol="0" anchor="ctr"/>
           <a:lstStyle/>
           <a:p>
-            <a:pPr indent="0" marL="0">
+            <a:pPr marL="0" indent="0">
               <a:buNone/>
             </a:pPr>
             <a:r>
@@ -2471,7 +4039,7 @@
           <a:bodyPr wrap="square" lIns="0" tIns="0" rIns="0" bIns="0" rtlCol="0" anchor="t"/>
           <a:lstStyle/>
           <a:p>
-            <a:pPr indent="0" marL="0">
+            <a:pPr marL="0" indent="0">
               <a:lnSpc>
                 <a:spcPts val="1700"/>
               </a:lnSpc>
@@ -2516,6 +4084,13 @@
             <a:prstDash val="solid"/>
           </a:ln>
         </p:spPr>
+        <p:txBody>
+          <a:bodyPr/>
+          <a:lstStyle/>
+          <a:p>
+            <a:endParaRPr lang="es-PE"/>
+          </a:p>
+        </p:txBody>
       </p:sp>
       <p:sp>
         <p:nvSpPr>
@@ -2538,7 +4113,7 @@
           <a:bodyPr wrap="square" lIns="0" tIns="0" rIns="0" bIns="0" rtlCol="0" anchor="ctr"/>
           <a:lstStyle/>
           <a:p>
-            <a:pPr indent="0" marL="0">
+            <a:pPr marL="0" indent="0">
               <a:buNone/>
             </a:pPr>
             <a:r>
@@ -2577,7 +4152,7 @@
           <a:bodyPr wrap="square" lIns="0" tIns="0" rIns="0" bIns="0" rtlCol="0" anchor="ctr"/>
           <a:lstStyle/>
           <a:p>
-            <a:pPr indent="0" marL="0">
+            <a:pPr marL="0" indent="0">
               <a:buNone/>
             </a:pPr>
             <a:r>
@@ -2616,7 +4191,7 @@
           <a:bodyPr wrap="square" lIns="0" tIns="0" rIns="0" bIns="0" rtlCol="0" anchor="t"/>
           <a:lstStyle/>
           <a:p>
-            <a:pPr indent="0" marL="0">
+            <a:pPr marL="0" indent="0">
               <a:lnSpc>
                 <a:spcPts val="1700"/>
               </a:lnSpc>
@@ -2661,6 +4236,13 @@
             <a:prstDash val="solid"/>
           </a:ln>
         </p:spPr>
+        <p:txBody>
+          <a:bodyPr/>
+          <a:lstStyle/>
+          <a:p>
+            <a:endParaRPr lang="es-PE"/>
+          </a:p>
+        </p:txBody>
       </p:sp>
       <p:sp>
         <p:nvSpPr>
@@ -2683,7 +4265,7 @@
           <a:bodyPr wrap="square" lIns="0" tIns="0" rIns="0" bIns="0" rtlCol="0" anchor="ctr"/>
           <a:lstStyle/>
           <a:p>
-            <a:pPr indent="0" marL="0">
+            <a:pPr marL="0" indent="0">
               <a:buNone/>
             </a:pPr>
             <a:r>
@@ -2722,7 +4304,7 @@
           <a:bodyPr wrap="square" lIns="0" tIns="0" rIns="0" bIns="0" rtlCol="0" anchor="ctr"/>
           <a:lstStyle/>
           <a:p>
-            <a:pPr indent="0" marL="0">
+            <a:pPr marL="0" indent="0">
               <a:buNone/>
             </a:pPr>
             <a:r>
@@ -2761,7 +4343,7 @@
           <a:bodyPr wrap="square" lIns="0" tIns="0" rIns="0" bIns="0" rtlCol="0" anchor="t"/>
           <a:lstStyle/>
           <a:p>
-            <a:pPr indent="0" marL="0">
+            <a:pPr marL="0" indent="0">
               <a:lnSpc>
                 <a:spcPts val="1700"/>
               </a:lnSpc>
@@ -2809,46 +4391,42 @@
       </p:grpSpPr>
       <p:sp>
         <p:nvSpPr>
-          <p:cNvPr id="2" name="Text 0"/>
+          <p:cNvPr id="2" name="TextBox 1"/>
           <p:cNvSpPr txBox="1"/>
           <p:nvPr/>
         </p:nvSpPr>
         <p:spPr>
           <a:xfrm>
-            <a:off x="886968" y="521208"/>
+            <a:off x="886968" y="521207"/>
             <a:ext cx="10405872" cy="640080"/>
           </a:xfrm>
           <a:prstGeom prst="rect">
             <a:avLst/>
           </a:prstGeom>
           <a:noFill/>
-          <a:ln/>
-        </p:spPr>
-        <p:txBody>
-          <a:bodyPr wrap="square" lIns="0" tIns="0" rIns="0" bIns="0" rtlCol="0" anchor="ctr"/>
-          <a:lstStyle/>
-          <a:p>
-            <a:pPr indent="0" marL="0">
-              <a:buNone/>
-            </a:pPr>
-            <a:r>
-              <a:rPr lang="en-US" sz="2800" b="1" dirty="0">
+        </p:spPr>
+        <p:txBody>
+          <a:bodyPr wrap="square" lIns="0" rIns="0" tIns="0" bIns="0" anchor="t">
+            <a:spAutoFit/>
+          </a:bodyPr>
+          <a:lstStyle/>
+          <a:p>
+            <a:pPr algn="l"/>
+            <a:r>
+              <a:rPr sz="2800" b="1" i="0">
                 <a:solidFill>
                   <a:srgbClr val="073269"/>
                 </a:solidFill>
-                <a:latin typeface="Calibri" pitchFamily="34" charset="0"/>
-                <a:ea typeface="Calibri" pitchFamily="34" charset="-122"/>
-                <a:cs typeface="Calibri" pitchFamily="34" charset="-120"/>
+                <a:latin typeface="Calibri"/>
               </a:rPr>
-              <a:t>III. Principales hallazgos</a:t>
-            </a:r>
-            <a:endParaRPr lang="en-US" sz="2800" dirty="0"/>
-          </a:p>
-        </p:txBody>
-      </p:sp>
-      <p:sp>
-        <p:nvSpPr>
-          <p:cNvPr id="3" name="Shape 1"/>
+              <a:t>III. Hallazgos: magnitud de la salida al cierre</a:t>
+            </a:r>
+          </a:p>
+        </p:txBody>
+      </p:sp>
+      <p:sp>
+        <p:nvSpPr>
+          <p:cNvPr id="3" name="Rectangle 2"/>
           <p:cNvSpPr/>
           <p:nvPr/>
         </p:nvSpPr>
@@ -2863,366 +4441,122 @@
           <a:solidFill>
             <a:srgbClr val="C8A24B"/>
           </a:solidFill>
-          <a:ln/>
-        </p:spPr>
-      </p:sp>
-      <p:sp>
-        <p:nvSpPr>
-          <p:cNvPr id="4" name="Text 2"/>
+          <a:ln>
+            <a:noFill/>
+          </a:ln>
+          <a:effectLst/>
+        </p:spPr>
+        <p:style>
+          <a:lnRef idx="1">
+            <a:schemeClr val="accent1"/>
+          </a:lnRef>
+          <a:fillRef idx="3">
+            <a:schemeClr val="accent1"/>
+          </a:fillRef>
+          <a:effectRef idx="2">
+            <a:schemeClr val="accent1"/>
+          </a:effectRef>
+          <a:fontRef idx="minor">
+            <a:schemeClr val="lt1"/>
+          </a:fontRef>
+        </p:style>
+        <p:txBody>
+          <a:bodyPr rtlCol="0" anchor="ctr"/>
+          <a:lstStyle/>
+          <a:p>
+            <a:pPr algn="ctr"/>
+          </a:p>
+        </p:txBody>
+      </p:sp>
+      <p:sp>
+        <p:nvSpPr>
+          <p:cNvPr id="4" name="TextBox 3"/>
           <p:cNvSpPr txBox="1"/>
           <p:nvPr/>
         </p:nvSpPr>
         <p:spPr>
           <a:xfrm>
             <a:off x="886968" y="1783080"/>
-            <a:ext cx="320040" cy="274320"/>
+            <a:ext cx="10405872" cy="1280160"/>
           </a:xfrm>
           <a:prstGeom prst="rect">
             <a:avLst/>
           </a:prstGeom>
           <a:noFill/>
-          <a:ln/>
-        </p:spPr>
-        <p:txBody>
-          <a:bodyPr wrap="square" lIns="0" tIns="0" rIns="0" bIns="0" rtlCol="0" anchor="t"/>
-          <a:lstStyle/>
-          <a:p>
-            <a:pPr indent="0" marL="0">
-              <a:buNone/>
+        </p:spPr>
+        <p:txBody>
+          <a:bodyPr wrap="square" lIns="0" rIns="0" tIns="0" bIns="0" anchor="t">
+            <a:spAutoFit/>
+          </a:bodyPr>
+          <a:lstStyle/>
+          <a:p>
+            <a:pPr algn="just">
+              <a:lnSpc>
+                <a:spcPts val="2400"/>
+              </a:lnSpc>
             </a:pPr>
             <a:r>
-              <a:rPr lang="en-US" sz="1500" b="1" dirty="0">
-                <a:solidFill>
-                  <a:srgbClr val="C8A24B"/>
-                </a:solidFill>
-                <a:latin typeface="Calibri" pitchFamily="34" charset="0"/>
-                <a:ea typeface="Calibri" pitchFamily="34" charset="-122"/>
-                <a:cs typeface="Calibri" pitchFamily="34" charset="-120"/>
+              <a:rPr sz="1600" b="0" i="0">
+                <a:solidFill>
+                  <a:srgbClr val="002060"/>
+                </a:solidFill>
+                <a:latin typeface="Calibri"/>
               </a:rPr>
-              <a:t>1</a:t>
-            </a:r>
-            <a:endParaRPr lang="en-US" sz="1500" dirty="0"/>
-          </a:p>
-        </p:txBody>
-      </p:sp>
-      <p:sp>
-        <p:nvSpPr>
-          <p:cNvPr id="5" name="Text 3"/>
+              <a:t>Al inicio del período, los últimos cinco días hábiles de cada cierre trimestral se encontraban prácticamente equilibrados. En la actualidad se observa una salida neta sostenida y creciente: el índice pasa de 100 en 2010 a 1.151 en 2025. El cambio se registra alrededor de 2018–2019 y sugiere una modificación de régimen, no una simple intensificación del fenómeno previo.</a:t>
+            </a:r>
+          </a:p>
+        </p:txBody>
+      </p:sp>
+      <p:graphicFrame>
+        <p:nvGraphicFramePr>
+          <p:cNvPr id="5" name="Chart 4"/>
+          <p:cNvGraphicFramePr>
+            <a:graphicFrameLocks noGrp="1"/>
+          </p:cNvGraphicFramePr>
+          <p:nvPr/>
+        </p:nvGraphicFramePr>
+        <p:xfrm>
+          <a:off x="886968" y="3246120"/>
+          <a:ext cx="10405872" cy="2606040"/>
+        </p:xfrm>
+        <a:graphic>
+          <a:graphicData uri="http://schemas.openxmlformats.org/drawingml/2006/chart">
+            <c:chart xmlns:c="http://schemas.openxmlformats.org/drawingml/2006/chart" r:id="rId3"/>
+          </a:graphicData>
+        </a:graphic>
+      </p:graphicFrame>
+      <p:sp>
+        <p:nvSpPr>
+          <p:cNvPr id="6" name="TextBox 5"/>
           <p:cNvSpPr txBox="1"/>
           <p:nvPr/>
         </p:nvSpPr>
         <p:spPr>
           <a:xfrm>
-            <a:off x="1271016" y="1783080"/>
-            <a:ext cx="4572000" cy="274320"/>
+            <a:off x="886968" y="5989320"/>
+            <a:ext cx="10405872" cy="274320"/>
           </a:xfrm>
           <a:prstGeom prst="rect">
             <a:avLst/>
           </a:prstGeom>
           <a:noFill/>
-          <a:ln/>
-        </p:spPr>
-        <p:txBody>
-          <a:bodyPr wrap="square" lIns="0" tIns="0" rIns="0" bIns="0" rtlCol="0" anchor="t"/>
-          <a:lstStyle/>
-          <a:p>
-            <a:pPr indent="0" marL="0">
-              <a:buNone/>
-            </a:pPr>
-            <a:r>
-              <a:rPr lang="en-US" sz="1600" b="1" dirty="0">
-                <a:solidFill>
-                  <a:srgbClr val="073269"/>
-                </a:solidFill>
-                <a:latin typeface="Calibri" pitchFamily="34" charset="0"/>
-                <a:ea typeface="Calibri" pitchFamily="34" charset="-122"/>
-                <a:cs typeface="Calibri" pitchFamily="34" charset="-120"/>
+        </p:spPr>
+        <p:txBody>
+          <a:bodyPr wrap="square" lIns="0" rIns="0" tIns="0" bIns="0" anchor="t">
+            <a:spAutoFit/>
+          </a:bodyPr>
+          <a:lstStyle/>
+          <a:p>
+            <a:pPr algn="l"/>
+            <a:r>
+              <a:rPr sz="1100" b="0" i="1">
+                <a:solidFill>
+                  <a:srgbClr val="767676"/>
+                </a:solidFill>
+                <a:latin typeface="Calibri"/>
               </a:rPr>
-              <a:t>Magnitud</a:t>
-            </a:r>
-            <a:endParaRPr lang="en-US" sz="1600" dirty="0"/>
-          </a:p>
-        </p:txBody>
-      </p:sp>
-      <p:sp>
-        <p:nvSpPr>
-          <p:cNvPr id="6" name="Text 4"/>
-          <p:cNvSpPr txBox="1"/>
-          <p:nvPr/>
-        </p:nvSpPr>
-        <p:spPr>
-          <a:xfrm>
-            <a:off x="1271016" y="2112264"/>
-            <a:ext cx="10021824" cy="1280160"/>
-          </a:xfrm>
-          <a:prstGeom prst="rect">
-            <a:avLst/>
-          </a:prstGeom>
-          <a:noFill/>
-          <a:ln/>
-        </p:spPr>
-        <p:txBody>
-          <a:bodyPr wrap="square" lIns="0" tIns="0" rIns="0" bIns="0" rtlCol="0" anchor="t"/>
-          <a:lstStyle/>
-          <a:p>
-            <a:pPr algn="just" indent="0" marL="0">
-              <a:lnSpc>
-                <a:spcPts val="2200"/>
-              </a:lnSpc>
-              <a:buNone/>
-            </a:pPr>
-            <a:r>
-              <a:rPr lang="en-US" sz="1500" dirty="0">
-                <a:solidFill>
-                  <a:srgbClr val="002060"/>
-                </a:solidFill>
-                <a:latin typeface="Calibri" pitchFamily="34" charset="0"/>
-                <a:ea typeface="Calibri" pitchFamily="34" charset="-122"/>
-                <a:cs typeface="Calibri" pitchFamily="34" charset="-120"/>
-              </a:rPr>
-              <a:t>Al inicio del período, los últimos cinco días hábiles de cada cierre trimestral se encontraban prácticamente equilibrados. En la actualidad se observa una salida neta sostenida y creciente. El cambio se registra alrededor de 2018–2019 y sugiere una modificación de régimen, no una simple intensificación del fenómeno previo.</a:t>
-            </a:r>
-            <a:endParaRPr lang="en-US" sz="1500" dirty="0"/>
-          </a:p>
-        </p:txBody>
-      </p:sp>
-      <p:sp>
-        <p:nvSpPr>
-          <p:cNvPr id="7" name="Text 5"/>
-          <p:cNvSpPr txBox="1"/>
-          <p:nvPr/>
-        </p:nvSpPr>
-        <p:spPr>
-          <a:xfrm>
-            <a:off x="886968" y="3739896"/>
-            <a:ext cx="320040" cy="274320"/>
-          </a:xfrm>
-          <a:prstGeom prst="rect">
-            <a:avLst/>
-          </a:prstGeom>
-          <a:noFill/>
-          <a:ln/>
-        </p:spPr>
-        <p:txBody>
-          <a:bodyPr wrap="square" lIns="0" tIns="0" rIns="0" bIns="0" rtlCol="0" anchor="t"/>
-          <a:lstStyle/>
-          <a:p>
-            <a:pPr indent="0" marL="0">
-              <a:buNone/>
-            </a:pPr>
-            <a:r>
-              <a:rPr lang="en-US" sz="1500" b="1" dirty="0">
-                <a:solidFill>
-                  <a:srgbClr val="C8A24B"/>
-                </a:solidFill>
-                <a:latin typeface="Calibri" pitchFamily="34" charset="0"/>
-                <a:ea typeface="Calibri" pitchFamily="34" charset="-122"/>
-                <a:cs typeface="Calibri" pitchFamily="34" charset="-120"/>
-              </a:rPr>
-              <a:t>2</a:t>
-            </a:r>
-            <a:endParaRPr lang="en-US" sz="1500" dirty="0"/>
-          </a:p>
-        </p:txBody>
-      </p:sp>
-      <p:sp>
-        <p:nvSpPr>
-          <p:cNvPr id="8" name="Text 6"/>
-          <p:cNvSpPr txBox="1"/>
-          <p:nvPr/>
-        </p:nvSpPr>
-        <p:spPr>
-          <a:xfrm>
-            <a:off x="1271016" y="3739896"/>
-            <a:ext cx="4572000" cy="274320"/>
-          </a:xfrm>
-          <a:prstGeom prst="rect">
-            <a:avLst/>
-          </a:prstGeom>
-          <a:noFill/>
-          <a:ln/>
-        </p:spPr>
-        <p:txBody>
-          <a:bodyPr wrap="square" lIns="0" tIns="0" rIns="0" bIns="0" rtlCol="0" anchor="t"/>
-          <a:lstStyle/>
-          <a:p>
-            <a:pPr indent="0" marL="0">
-              <a:buNone/>
-            </a:pPr>
-            <a:r>
-              <a:rPr lang="en-US" sz="1600" b="1" dirty="0">
-                <a:solidFill>
-                  <a:srgbClr val="073269"/>
-                </a:solidFill>
-                <a:latin typeface="Calibri" pitchFamily="34" charset="0"/>
-                <a:ea typeface="Calibri" pitchFamily="34" charset="-122"/>
-                <a:cs typeface="Calibri" pitchFamily="34" charset="-120"/>
-              </a:rPr>
-              <a:t>Distribución intramensual</a:t>
-            </a:r>
-            <a:endParaRPr lang="en-US" sz="1600" dirty="0"/>
-          </a:p>
-        </p:txBody>
-      </p:sp>
-      <p:sp>
-        <p:nvSpPr>
-          <p:cNvPr id="9" name="Text 7"/>
-          <p:cNvSpPr txBox="1"/>
-          <p:nvPr/>
-        </p:nvSpPr>
-        <p:spPr>
-          <a:xfrm>
-            <a:off x="1271016" y="4069080"/>
-            <a:ext cx="10021824" cy="640080"/>
-          </a:xfrm>
-          <a:prstGeom prst="rect">
-            <a:avLst/>
-          </a:prstGeom>
-          <a:noFill/>
-          <a:ln/>
-        </p:spPr>
-        <p:txBody>
-          <a:bodyPr wrap="square" lIns="0" tIns="0" rIns="0" bIns="0" rtlCol="0" anchor="t"/>
-          <a:lstStyle/>
-          <a:p>
-            <a:pPr algn="just" indent="0" marL="0">
-              <a:lnSpc>
-                <a:spcPts val="2200"/>
-              </a:lnSpc>
-              <a:buNone/>
-            </a:pPr>
-            <a:r>
-              <a:rPr lang="en-US" sz="1500" dirty="0">
-                <a:solidFill>
-                  <a:srgbClr val="002060"/>
-                </a:solidFill>
-                <a:latin typeface="Calibri" pitchFamily="34" charset="0"/>
-                <a:ea typeface="Calibri" pitchFamily="34" charset="-122"/>
-                <a:cs typeface="Calibri" pitchFamily="34" charset="-120"/>
-              </a:rPr>
-              <a:t>La salida no se distribuye de manera uniforme a lo largo del mes. El sistema deposita al inicio y retira hacia el cierre, con un pico considerablemente más pronunciado en los cierres trimestrales.</a:t>
-            </a:r>
-            <a:endParaRPr lang="en-US" sz="1500" dirty="0"/>
-          </a:p>
-        </p:txBody>
-      </p:sp>
-      <p:sp>
-        <p:nvSpPr>
-          <p:cNvPr id="10" name="Text 8"/>
-          <p:cNvSpPr txBox="1"/>
-          <p:nvPr/>
-        </p:nvSpPr>
-        <p:spPr>
-          <a:xfrm>
-            <a:off x="886968" y="5056632"/>
-            <a:ext cx="320040" cy="274320"/>
-          </a:xfrm>
-          <a:prstGeom prst="rect">
-            <a:avLst/>
-          </a:prstGeom>
-          <a:noFill/>
-          <a:ln/>
-        </p:spPr>
-        <p:txBody>
-          <a:bodyPr wrap="square" lIns="0" tIns="0" rIns="0" bIns="0" rtlCol="0" anchor="t"/>
-          <a:lstStyle/>
-          <a:p>
-            <a:pPr indent="0" marL="0">
-              <a:buNone/>
-            </a:pPr>
-            <a:r>
-              <a:rPr lang="en-US" sz="1500" b="1" dirty="0">
-                <a:solidFill>
-                  <a:srgbClr val="C8A24B"/>
-                </a:solidFill>
-                <a:latin typeface="Calibri" pitchFamily="34" charset="0"/>
-                <a:ea typeface="Calibri" pitchFamily="34" charset="-122"/>
-                <a:cs typeface="Calibri" pitchFamily="34" charset="-120"/>
-              </a:rPr>
-              <a:t>3</a:t>
-            </a:r>
-            <a:endParaRPr lang="en-US" sz="1500" dirty="0"/>
-          </a:p>
-        </p:txBody>
-      </p:sp>
-      <p:sp>
-        <p:nvSpPr>
-          <p:cNvPr id="11" name="Text 9"/>
-          <p:cNvSpPr txBox="1"/>
-          <p:nvPr/>
-        </p:nvSpPr>
-        <p:spPr>
-          <a:xfrm>
-            <a:off x="1271016" y="5056632"/>
-            <a:ext cx="4572000" cy="274320"/>
-          </a:xfrm>
-          <a:prstGeom prst="rect">
-            <a:avLst/>
-          </a:prstGeom>
-          <a:noFill/>
-          <a:ln/>
-        </p:spPr>
-        <p:txBody>
-          <a:bodyPr wrap="square" lIns="0" tIns="0" rIns="0" bIns="0" rtlCol="0" anchor="t"/>
-          <a:lstStyle/>
-          <a:p>
-            <a:pPr indent="0" marL="0">
-              <a:buNone/>
-            </a:pPr>
-            <a:r>
-              <a:rPr lang="en-US" sz="1600" b="1" dirty="0">
-                <a:solidFill>
-                  <a:srgbClr val="073269"/>
-                </a:solidFill>
-                <a:latin typeface="Calibri" pitchFamily="34" charset="0"/>
-                <a:ea typeface="Calibri" pitchFamily="34" charset="-122"/>
-                <a:cs typeface="Calibri" pitchFamily="34" charset="-120"/>
-              </a:rPr>
-              <a:t>Composición por entidad</a:t>
-            </a:r>
-            <a:endParaRPr lang="en-US" sz="1600" dirty="0"/>
-          </a:p>
-        </p:txBody>
-      </p:sp>
-      <p:sp>
-        <p:nvSpPr>
-          <p:cNvPr id="12" name="Text 10"/>
-          <p:cNvSpPr txBox="1"/>
-          <p:nvPr/>
-        </p:nvSpPr>
-        <p:spPr>
-          <a:xfrm>
-            <a:off x="1271016" y="5385816"/>
-            <a:ext cx="10021824" cy="640080"/>
-          </a:xfrm>
-          <a:prstGeom prst="rect">
-            <a:avLst/>
-          </a:prstGeom>
-          <a:noFill/>
-          <a:ln/>
-        </p:spPr>
-        <p:txBody>
-          <a:bodyPr wrap="square" lIns="0" tIns="0" rIns="0" bIns="0" rtlCol="0" anchor="t"/>
-          <a:lstStyle/>
-          <a:p>
-            <a:pPr algn="just" indent="0" marL="0">
-              <a:lnSpc>
-                <a:spcPts val="2200"/>
-              </a:lnSpc>
-              <a:buNone/>
-            </a:pPr>
-            <a:r>
-              <a:rPr lang="en-US" sz="1500" dirty="0">
-                <a:solidFill>
-                  <a:srgbClr val="002060"/>
-                </a:solidFill>
-                <a:latin typeface="Calibri" pitchFamily="34" charset="0"/>
-                <a:ea typeface="Calibri" pitchFamily="34" charset="-122"/>
-                <a:cs typeface="Calibri" pitchFamily="34" charset="-120"/>
-              </a:rPr>
-              <a:t>Una entidad concentra la mayor parte de la salida al cierre, en una proporción superior a la que explicaría su tamaño relativo. Registra cinco años consecutivos por encima del 75 % desde 2022.</a:t>
-            </a:r>
-            <a:endParaRPr lang="en-US" sz="1500" dirty="0"/>
+              <a:t>Salida neta del sistema en la ventana de cierre trimestral, índice 2010 = 100. Se excluye 2026 por tratarse de un año parcial.</a:t>
+            </a:r>
           </a:p>
         </p:txBody>
       </p:sp>
@@ -3272,7 +4606,7 @@
           <a:bodyPr wrap="square" lIns="0" tIns="0" rIns="0" bIns="0" rtlCol="0" anchor="ctr"/>
           <a:lstStyle/>
           <a:p>
-            <a:pPr indent="0" marL="0">
+            <a:pPr marL="0" indent="0">
               <a:buNone/>
             </a:pPr>
             <a:r>
@@ -3309,6 +4643,13 @@
           </a:solidFill>
           <a:ln/>
         </p:spPr>
+        <p:txBody>
+          <a:bodyPr/>
+          <a:lstStyle/>
+          <a:p>
+            <a:endParaRPr lang="es-PE"/>
+          </a:p>
+        </p:txBody>
       </p:sp>
       <p:sp>
         <p:nvSpPr>
@@ -3331,7 +4672,7 @@
           <a:bodyPr wrap="square" lIns="0" tIns="0" rIns="0" bIns="0" rtlCol="0" anchor="t"/>
           <a:lstStyle/>
           <a:p>
-            <a:pPr algn="just" indent="0" marL="0">
+            <a:pPr marL="0" indent="0" algn="just">
               <a:lnSpc>
                 <a:spcPts val="2400"/>
               </a:lnSpc>
@@ -3354,14 +4695,14 @@
       </p:sp>
       <p:pic>
         <p:nvPicPr>
-          <p:cNvPr id="5" name="Image 0" descr="preencoded.png">    </p:cNvPr>
+          <p:cNvPr id="5" name="Image 0" descr="preencoded.png"/>
           <p:cNvPicPr>
             <a:picLocks noChangeAspect="1"/>
           </p:cNvPicPr>
           <p:nvPr/>
         </p:nvPicPr>
         <p:blipFill>
-          <a:blip r:embed="rId1"/>
+          <a:blip r:embed="rId3"/>
           <a:stretch>
             <a:fillRect/>
           </a:stretch>
@@ -3397,7 +4738,7 @@
           <a:bodyPr wrap="square" lIns="0" tIns="0" rIns="0" bIns="0" rtlCol="0" anchor="t"/>
           <a:lstStyle/>
           <a:p>
-            <a:pPr indent="0" marL="0">
+            <a:pPr marL="0" indent="0">
               <a:buNone/>
             </a:pPr>
             <a:r>
@@ -3461,7 +4802,7 @@
           <a:bodyPr wrap="square" lIns="0" tIns="0" rIns="0" bIns="0" rtlCol="0" anchor="ctr"/>
           <a:lstStyle/>
           <a:p>
-            <a:pPr indent="0" marL="0">
+            <a:pPr marL="0" indent="0">
               <a:buNone/>
             </a:pPr>
             <a:r>
@@ -3498,6 +4839,13 @@
           </a:solidFill>
           <a:ln/>
         </p:spPr>
+        <p:txBody>
+          <a:bodyPr/>
+          <a:lstStyle/>
+          <a:p>
+            <a:endParaRPr lang="es-PE"/>
+          </a:p>
+        </p:txBody>
       </p:sp>
       <p:sp>
         <p:nvSpPr>
@@ -3520,7 +4868,7 @@
           <a:bodyPr wrap="square" lIns="0" tIns="0" rIns="0" bIns="0" rtlCol="0" anchor="t"/>
           <a:lstStyle/>
           <a:p>
-            <a:pPr algn="just" indent="0" marL="0">
+            <a:pPr marL="0" indent="0" algn="just">
               <a:lnSpc>
                 <a:spcPts val="2400"/>
               </a:lnSpc>
@@ -3535,7 +4883,29 @@
                 <a:ea typeface="Calibri" pitchFamily="34" charset="-122"/>
                 <a:cs typeface="Calibri" pitchFamily="34" charset="-120"/>
               </a:rPr>
-              <a:t>Una posición de 1.100 millones con vencimiento al tercer día resultaría igualmente insuficiente: el segundo día el déficit acumulado ascendía ya a 800 millones. La escalera de vencimientos debe cubrir la trayectoria en cada fecha, no únicamente al vencimiento. El indicador correspondiente es el máximo drawdown desde el origen, definido como la mayor caída del flujo acumulado respecto del punto de partida dentro del plazo considerado.</a:t>
+              <a:t>Una posición de 1.100 millones con vencimiento al tercer día resultaría igualmente insuficiente: el segundo día el déficit acumulado ascendía ya a 800 millones. La escalera de vencimientos debe cubrir la trayectoria en cada fecha, no únicamente al vencimiento. En </a:t>
+            </a:r>
+            <a:r>
+              <a:rPr lang="en-US" sz="1600" dirty="0" err="1">
+                <a:solidFill>
+                  <a:srgbClr val="002060"/>
+                </a:solidFill>
+                <a:latin typeface="Calibri" pitchFamily="34" charset="0"/>
+                <a:ea typeface="Calibri" pitchFamily="34" charset="-122"/>
+                <a:cs typeface="Calibri" pitchFamily="34" charset="-120"/>
+              </a:rPr>
+              <a:t>consecuencia</a:t>
+            </a:r>
+            <a:r>
+              <a:rPr lang="en-US" sz="1600" dirty="0">
+                <a:solidFill>
+                  <a:srgbClr val="002060"/>
+                </a:solidFill>
+                <a:latin typeface="Calibri" pitchFamily="34" charset="0"/>
+                <a:ea typeface="Calibri" pitchFamily="34" charset="-122"/>
+                <a:cs typeface="Calibri" pitchFamily="34" charset="-120"/>
+              </a:rPr>
+              <a:t>, el indicador correspondiente es el máximo drawdown desde el origen, definido como la mayor caída del flujo acumulado respecto del punto de partida dentro del plazo considerado.</a:t>
             </a:r>
             <a:endParaRPr lang="en-US" sz="1600" dirty="0"/>
           </a:p>
@@ -3543,14 +4913,14 @@
       </p:sp>
       <p:pic>
         <p:nvPicPr>
-          <p:cNvPr id="5" name="Image 0" descr="preencoded.png">    </p:cNvPr>
+          <p:cNvPr id="5" name="Image 0" descr="preencoded.png"/>
           <p:cNvPicPr>
             <a:picLocks noChangeAspect="1"/>
           </p:cNvPicPr>
           <p:nvPr/>
         </p:nvPicPr>
         <p:blipFill>
-          <a:blip r:embed="rId1"/>
+          <a:blip r:embed="rId3"/>
           <a:stretch>
             <a:fillRect/>
           </a:stretch>
@@ -3586,7 +4956,7 @@
           <a:bodyPr wrap="square" lIns="0" tIns="0" rIns="0" bIns="0" rtlCol="0" anchor="t"/>
           <a:lstStyle/>
           <a:p>
-            <a:pPr indent="0" marL="0">
+            <a:pPr marL="0" indent="0">
               <a:buNone/>
             </a:pPr>
             <a:r>
@@ -3650,7 +5020,7 @@
           <a:bodyPr wrap="square" lIns="0" tIns="0" rIns="0" bIns="0" rtlCol="0" anchor="ctr"/>
           <a:lstStyle/>
           <a:p>
-            <a:pPr indent="0" marL="0">
+            <a:pPr marL="0" indent="0">
               <a:buNone/>
             </a:pPr>
             <a:r>
@@ -3687,6 +5057,13 @@
           </a:solidFill>
           <a:ln/>
         </p:spPr>
+        <p:txBody>
+          <a:bodyPr/>
+          <a:lstStyle/>
+          <a:p>
+            <a:endParaRPr lang="es-PE"/>
+          </a:p>
+        </p:txBody>
       </p:sp>
       <p:sp>
         <p:nvSpPr>
@@ -3709,7 +5086,7 @@
           <a:bodyPr wrap="square" lIns="0" tIns="0" rIns="0" bIns="0" rtlCol="0" anchor="t"/>
           <a:lstStyle/>
           <a:p>
-            <a:pPr algn="just" indent="0" marL="0">
+            <a:pPr marL="0" indent="0" algn="just">
               <a:lnSpc>
                 <a:spcPts val="2400"/>
               </a:lnSpc>
@@ -3724,7 +5101,29 @@
                 <a:ea typeface="Calibri" pitchFamily="34" charset="-122"/>
                 <a:cs typeface="Calibri" pitchFamily="34" charset="-120"/>
               </a:rPr>
-              <a:t>En ausencia de conocimiento pleno de los retiros, el entregable no puede ser una estimación puntual. La función de costo es asimétrica: quedarse corto obliga a liquidar una posición o a fondearse de un portafolio de mayor plazo, mientras que quedarse largo representa unos pocos puntos básicos de menor rendimiento. El criterio prudente es dimensionar contra un percentil de la caída.</a:t>
+              <a:t>En ausencia de conocimiento pleno de los retiros, el entregable no puede ser una estimación puntual. La función de costo es asimétrica: quedarse corto obliga a liquidar una posición o a fondearse de un portafolio de mayor plazo, mientras que quedarse largo representa unos pocos puntos básicos de menor rendimiento. Por </a:t>
+            </a:r>
+            <a:r>
+              <a:rPr lang="en-US" sz="1600" dirty="0" err="1">
+                <a:solidFill>
+                  <a:srgbClr val="002060"/>
+                </a:solidFill>
+                <a:latin typeface="Calibri" pitchFamily="34" charset="0"/>
+                <a:ea typeface="Calibri" pitchFamily="34" charset="-122"/>
+                <a:cs typeface="Calibri" pitchFamily="34" charset="-120"/>
+              </a:rPr>
+              <a:t>ende</a:t>
+            </a:r>
+            <a:r>
+              <a:rPr lang="en-US" sz="1600" dirty="0">
+                <a:solidFill>
+                  <a:srgbClr val="002060"/>
+                </a:solidFill>
+                <a:latin typeface="Calibri" pitchFamily="34" charset="0"/>
+                <a:ea typeface="Calibri" pitchFamily="34" charset="-122"/>
+                <a:cs typeface="Calibri" pitchFamily="34" charset="-120"/>
+              </a:rPr>
+              <a:t>, el criterio prudente es dimensionar contra un percentil de la caída.</a:t>
             </a:r>
             <a:endParaRPr lang="en-US" sz="1600" dirty="0"/>
           </a:p>
@@ -3739,22 +5138,34 @@
           <p:nvPr>
             <p:extLst>
               <p:ext uri="{D42A27DB-BD31-4B8C-83A1-F6EECF244321}">
-                <p14:modId xmlns:p14="http://schemas.microsoft.com/office/powerpoint/2010/main" val="1579011935"/>
+                <p14:modId xmlns:p14="http://schemas.microsoft.com/office/powerpoint/2010/main" val="3280063796"/>
               </p:ext>
             </p:extLst>
           </p:nvPr>
         </p:nvGraphicFramePr>
         <p:xfrm>
           <a:off x="886968" y="3291840"/>
-          <a:ext cx="10405872" cy="914400"/>
+          <a:ext cx="10405872" cy="2296160"/>
         </p:xfrm>
         <a:graphic>
           <a:graphicData uri="http://schemas.openxmlformats.org/drawingml/2006/table">
             <a:tbl>
               <a:tblPr/>
               <a:tblGrid>
-                <a:gridCol w="2240280"/>
-                <a:gridCol w="8165592"/>
+                <a:gridCol w="2240280">
+                  <a:extLst>
+                    <a:ext uri="{9D8B030D-6E8A-4147-A177-3AD203B41FA5}">
+                      <a16:colId xmlns:a16="http://schemas.microsoft.com/office/drawing/2014/main" val="20000"/>
+                    </a:ext>
+                  </a:extLst>
+                </a:gridCol>
+                <a:gridCol w="8165592">
+                  <a:extLst>
+                    <a:ext uri="{9D8B030D-6E8A-4147-A177-3AD203B41FA5}">
+                      <a16:colId xmlns:a16="http://schemas.microsoft.com/office/drawing/2014/main" val="20001"/>
+                    </a:ext>
+                  </a:extLst>
+                </a:gridCol>
               </a:tblGrid>
               <a:tr h="0">
                 <a:tc>
@@ -3762,7 +5173,7 @@
                     <a:bodyPr/>
                     <a:lstStyle/>
                     <a:p>
-                      <a:pPr indent="0" marL="0">
+                      <a:pPr marL="0" indent="0">
                         <a:buNone/>
                       </a:pPr>
                       <a:r>
@@ -3783,7 +5194,7 @@
                       </a:endParaRPr>
                     </a:p>
                   </a:txBody>
-                  <a:tcPr marL="127000" marR="127000" marT="88900" marB="88900" anchor="t">
+                  <a:tcPr marL="127000" marR="127000" marT="88900" marB="88900">
                     <a:lnL w="9525" cap="flat" cmpd="sng" algn="ctr">
                       <a:solidFill>
                         <a:srgbClr val="D8DEE8"/>
@@ -3830,7 +5241,7 @@
                     <a:bodyPr/>
                     <a:lstStyle/>
                     <a:p>
-                      <a:pPr algn="just" indent="0" marL="0">
+                      <a:pPr marL="0" indent="0" algn="just">
                         <a:buNone/>
                       </a:pPr>
                       <a:r>
@@ -3851,7 +5262,7 @@
                       </a:endParaRPr>
                     </a:p>
                   </a:txBody>
-                  <a:tcPr marL="127000" marR="127000" marT="88900" marB="88900" anchor="t">
+                  <a:tcPr marL="127000" marR="127000" marT="88900" marB="88900">
                     <a:lnL w="9525" cap="flat" cmpd="sng" algn="ctr">
                       <a:solidFill>
                         <a:srgbClr val="D8DEE8"/>
@@ -3890,6 +5301,11 @@
                     </a:lnB>
                   </a:tcPr>
                 </a:tc>
+                <a:extLst>
+                  <a:ext uri="{0D108BD9-81ED-4DB2-BD59-A6C34878D82A}">
+                    <a16:rowId xmlns:a16="http://schemas.microsoft.com/office/drawing/2014/main" val="10000"/>
+                  </a:ext>
+                </a:extLst>
               </a:tr>
               <a:tr h="0">
                 <a:tc>
@@ -3897,7 +5313,7 @@
                     <a:bodyPr/>
                     <a:lstStyle/>
                     <a:p>
-                      <a:pPr indent="0" marL="0">
+                      <a:pPr marL="0" indent="0">
                         <a:buNone/>
                       </a:pPr>
                       <a:r>
@@ -3918,7 +5334,7 @@
                       </a:endParaRPr>
                     </a:p>
                   </a:txBody>
-                  <a:tcPr marL="127000" marR="127000" marT="88900" marB="88900" anchor="t">
+                  <a:tcPr marL="127000" marR="127000" marT="88900" marB="88900">
                     <a:lnL w="9525" cap="flat" cmpd="sng" algn="ctr">
                       <a:solidFill>
                         <a:srgbClr val="D8DEE8"/>
@@ -3965,7 +5381,7 @@
                     <a:bodyPr/>
                     <a:lstStyle/>
                     <a:p>
-                      <a:pPr algn="just" indent="0" marL="0">
+                      <a:pPr marL="0" indent="0" algn="just">
                         <a:buNone/>
                       </a:pPr>
                       <a:r>
@@ -3986,7 +5402,7 @@
                       </a:endParaRPr>
                     </a:p>
                   </a:txBody>
-                  <a:tcPr marL="127000" marR="127000" marT="88900" marB="88900" anchor="t">
+                  <a:tcPr marL="127000" marR="127000" marT="88900" marB="88900">
                     <a:lnL w="9525" cap="flat" cmpd="sng" algn="ctr">
                       <a:solidFill>
                         <a:srgbClr val="D8DEE8"/>
@@ -4025,6 +5441,11 @@
                     </a:lnB>
                   </a:tcPr>
                 </a:tc>
+                <a:extLst>
+                  <a:ext uri="{0D108BD9-81ED-4DB2-BD59-A6C34878D82A}">
+                    <a16:rowId xmlns:a16="http://schemas.microsoft.com/office/drawing/2014/main" val="10001"/>
+                  </a:ext>
+                </a:extLst>
               </a:tr>
               <a:tr h="0">
                 <a:tc>
@@ -4032,7 +5453,7 @@
                     <a:bodyPr/>
                     <a:lstStyle/>
                     <a:p>
-                      <a:pPr indent="0" marL="0">
+                      <a:pPr marL="0" indent="0">
                         <a:buNone/>
                       </a:pPr>
                       <a:r>
@@ -4053,7 +5474,7 @@
                       </a:endParaRPr>
                     </a:p>
                   </a:txBody>
-                  <a:tcPr marL="127000" marR="127000" marT="88900" marB="88900" anchor="t">
+                  <a:tcPr marL="127000" marR="127000" marT="88900" marB="88900">
                     <a:lnL w="9525" cap="flat" cmpd="sng" algn="ctr">
                       <a:solidFill>
                         <a:srgbClr val="D8DEE8"/>
@@ -4100,7 +5521,7 @@
                     <a:bodyPr/>
                     <a:lstStyle/>
                     <a:p>
-                      <a:pPr algn="just" indent="0" marL="0">
+                      <a:pPr marL="0" indent="0" algn="just">
                         <a:buNone/>
                       </a:pPr>
                       <a:r>
@@ -4112,7 +5533,95 @@
                           <a:ea typeface="Calibri" pitchFamily="34" charset="-122"/>
                           <a:cs typeface="Calibri" pitchFamily="34" charset="-120"/>
                         </a:rPr>
-                        <a:t>El flujo neto se modela mediante técnicas de aprendizaje automático. De dicho modelo se simulan trayectorias que preservan la correlación serial; cada una se acumula, se obtiene su caída máxima desde el origen y el percentil se calcula sobre esa distribución.</a:t>
+                        <a:t>El flujo neto se modela mediante técnicas de </a:t>
+                      </a:r>
+                      <a:r>
+                        <a:rPr lang="en-US" sz="1300" i="1" dirty="0">
+                          <a:solidFill>
+                            <a:srgbClr val="002060"/>
+                          </a:solidFill>
+                          <a:latin typeface="Calibri" pitchFamily="34" charset="0"/>
+                          <a:ea typeface="Calibri" pitchFamily="34" charset="-122"/>
+                          <a:cs typeface="Calibri" pitchFamily="34" charset="-120"/>
+                        </a:rPr>
+                        <a:t>machine learning</a:t>
+                      </a:r>
+                      <a:r>
+                        <a:rPr lang="en-US" sz="1300" dirty="0">
+                          <a:solidFill>
+                            <a:srgbClr val="002060"/>
+                          </a:solidFill>
+                          <a:latin typeface="Calibri" pitchFamily="34" charset="0"/>
+                          <a:ea typeface="Calibri" pitchFamily="34" charset="-122"/>
+                          <a:cs typeface="Calibri" pitchFamily="34" charset="-120"/>
+                        </a:rPr>
+                        <a:t>. A </a:t>
+                      </a:r>
+                      <a:r>
+                        <a:rPr lang="en-US" sz="1300" dirty="0" err="1">
+                          <a:solidFill>
+                            <a:srgbClr val="002060"/>
+                          </a:solidFill>
+                          <a:latin typeface="Calibri" pitchFamily="34" charset="0"/>
+                          <a:ea typeface="Calibri" pitchFamily="34" charset="-122"/>
+                          <a:cs typeface="Calibri" pitchFamily="34" charset="-120"/>
+                        </a:rPr>
+                        <a:t>partir</a:t>
+                      </a:r>
+                      <a:r>
+                        <a:rPr lang="en-US" sz="1300" dirty="0">
+                          <a:solidFill>
+                            <a:srgbClr val="002060"/>
+                          </a:solidFill>
+                          <a:latin typeface="Calibri" pitchFamily="34" charset="0"/>
+                          <a:ea typeface="Calibri" pitchFamily="34" charset="-122"/>
+                          <a:cs typeface="Calibri" pitchFamily="34" charset="-120"/>
+                        </a:rPr>
+                        <a:t> </a:t>
+                      </a:r>
+                      <a:r>
+                        <a:rPr lang="en-US" sz="1300" dirty="0" err="1">
+                          <a:solidFill>
+                            <a:srgbClr val="002060"/>
+                          </a:solidFill>
+                          <a:latin typeface="Calibri" pitchFamily="34" charset="0"/>
+                          <a:ea typeface="Calibri" pitchFamily="34" charset="-122"/>
+                          <a:cs typeface="Calibri" pitchFamily="34" charset="-120"/>
+                        </a:rPr>
+                        <a:t>dicho</a:t>
+                      </a:r>
+                      <a:r>
+                        <a:rPr lang="en-US" sz="1300" dirty="0">
+                          <a:solidFill>
+                            <a:srgbClr val="002060"/>
+                          </a:solidFill>
+                          <a:latin typeface="Calibri" pitchFamily="34" charset="0"/>
+                          <a:ea typeface="Calibri" pitchFamily="34" charset="-122"/>
+                          <a:cs typeface="Calibri" pitchFamily="34" charset="-120"/>
+                        </a:rPr>
+                        <a:t> </a:t>
+                      </a:r>
+                      <a:r>
+                        <a:rPr lang="en-US" sz="1300" dirty="0" err="1">
+                          <a:solidFill>
+                            <a:srgbClr val="002060"/>
+                          </a:solidFill>
+                          <a:latin typeface="Calibri" pitchFamily="34" charset="0"/>
+                          <a:ea typeface="Calibri" pitchFamily="34" charset="-122"/>
+                          <a:cs typeface="Calibri" pitchFamily="34" charset="-120"/>
+                        </a:rPr>
+                        <a:t>modelo</a:t>
+                      </a:r>
+                      <a:r>
+                        <a:rPr lang="en-US" sz="1300" dirty="0">
+                          <a:solidFill>
+                            <a:srgbClr val="002060"/>
+                          </a:solidFill>
+                          <a:latin typeface="Calibri" pitchFamily="34" charset="0"/>
+                          <a:ea typeface="Calibri" pitchFamily="34" charset="-122"/>
+                          <a:cs typeface="Calibri" pitchFamily="34" charset="-120"/>
+                        </a:rPr>
+                        <a:t>, se simulan trayectorias que preservan la correlación serial; cada una se acumula, se obtiene su caída máxima desde el origen y el percentil se calcula sobre esa distribución.</a:t>
                       </a:r>
                       <a:endParaRPr lang="en-US" sz="1300" dirty="0">
                         <a:latin typeface="Calibri" charset="0"/>
@@ -4121,7 +5630,7 @@
                       </a:endParaRPr>
                     </a:p>
                   </a:txBody>
-                  <a:tcPr marL="127000" marR="127000" marT="88900" marB="88900" anchor="t">
+                  <a:tcPr marL="127000" marR="127000" marT="88900" marB="88900">
                     <a:lnL w="9525" cap="flat" cmpd="sng" algn="ctr">
                       <a:solidFill>
                         <a:srgbClr val="D8DEE8"/>
@@ -4160,6 +5669,11 @@
                     </a:lnB>
                   </a:tcPr>
                 </a:tc>
+                <a:extLst>
+                  <a:ext uri="{0D108BD9-81ED-4DB2-BD59-A6C34878D82A}">
+                    <a16:rowId xmlns:a16="http://schemas.microsoft.com/office/drawing/2014/main" val="10002"/>
+                  </a:ext>
+                </a:extLst>
               </a:tr>
               <a:tr h="0">
                 <a:tc>
@@ -4167,7 +5681,7 @@
                     <a:bodyPr/>
                     <a:lstStyle/>
                     <a:p>
-                      <a:pPr indent="0" marL="0">
+                      <a:pPr marL="0" indent="0">
                         <a:buNone/>
                       </a:pPr>
                       <a:r>
@@ -4188,7 +5702,7 @@
                       </a:endParaRPr>
                     </a:p>
                   </a:txBody>
-                  <a:tcPr marL="127000" marR="127000" marT="88900" marB="88900" anchor="t">
+                  <a:tcPr marL="127000" marR="127000" marT="88900" marB="88900">
                     <a:lnL w="9525" cap="flat" cmpd="sng" algn="ctr">
                       <a:solidFill>
                         <a:srgbClr val="D8DEE8"/>
@@ -4235,7 +5749,7 @@
                     <a:bodyPr/>
                     <a:lstStyle/>
                     <a:p>
-                      <a:pPr algn="just" indent="0" marL="0">
+                      <a:pPr marL="0" indent="0" algn="just">
                         <a:buNone/>
                       </a:pPr>
                       <a:r>
@@ -4256,7 +5770,7 @@
                       </a:endParaRPr>
                     </a:p>
                   </a:txBody>
-                  <a:tcPr marL="127000" marR="127000" marT="88900" marB="88900" anchor="t">
+                  <a:tcPr marL="127000" marR="127000" marT="88900" marB="88900">
                     <a:lnL w="9525" cap="flat" cmpd="sng" algn="ctr">
                       <a:solidFill>
                         <a:srgbClr val="D8DEE8"/>
@@ -4295,6 +5809,11 @@
                     </a:lnB>
                   </a:tcPr>
                 </a:tc>
+                <a:extLst>
+                  <a:ext uri="{0D108BD9-81ED-4DB2-BD59-A6C34878D82A}">
+                    <a16:rowId xmlns:a16="http://schemas.microsoft.com/office/drawing/2014/main" val="10003"/>
+                  </a:ext>
+                </a:extLst>
               </a:tr>
             </a:tbl>
           </a:graphicData>
@@ -4346,7 +5865,7 @@
           <a:bodyPr wrap="square" lIns="0" tIns="0" rIns="0" bIns="0" rtlCol="0" anchor="ctr"/>
           <a:lstStyle/>
           <a:p>
-            <a:pPr indent="0" marL="0">
+            <a:pPr marL="0" indent="0">
               <a:buNone/>
             </a:pPr>
             <a:r>
@@ -4383,6 +5902,13 @@
           </a:solidFill>
           <a:ln/>
         </p:spPr>
+        <p:txBody>
+          <a:bodyPr/>
+          <a:lstStyle/>
+          <a:p>
+            <a:endParaRPr lang="es-PE"/>
+          </a:p>
+        </p:txBody>
       </p:sp>
       <p:sp>
         <p:nvSpPr>
@@ -4405,7 +5931,7 @@
           <a:bodyPr wrap="square" lIns="0" tIns="0" rIns="0" bIns="0" rtlCol="0" anchor="t"/>
           <a:lstStyle/>
           <a:p>
-            <a:pPr algn="just" indent="0" marL="0">
+            <a:pPr marL="0" indent="0" algn="just">
               <a:lnSpc>
                 <a:spcPts val="2400"/>
               </a:lnSpc>
@@ -4428,14 +5954,14 @@
       </p:sp>
       <p:pic>
         <p:nvPicPr>
-          <p:cNvPr id="5" name="Image 0" descr="preencoded.png">    </p:cNvPr>
+          <p:cNvPr id="5" name="Image 0" descr="preencoded.png"/>
           <p:cNvPicPr>
             <a:picLocks noChangeAspect="1"/>
           </p:cNvPicPr>
           <p:nvPr/>
         </p:nvPicPr>
         <p:blipFill>
-          <a:blip r:embed="rId1"/>
+          <a:blip r:embed="rId3"/>
           <a:stretch>
             <a:fillRect/>
           </a:stretch>
@@ -4471,7 +5997,7 @@
           <a:bodyPr wrap="square" lIns="0" tIns="0" rIns="0" bIns="0" rtlCol="0" anchor="t"/>
           <a:lstStyle/>
           <a:p>
-            <a:pPr indent="0" marL="0">
+            <a:pPr marL="0" indent="0">
               <a:buNone/>
             </a:pPr>
             <a:r>
@@ -4535,7 +6061,7 @@
           <a:bodyPr wrap="square" lIns="0" tIns="0" rIns="0" bIns="0" rtlCol="0" anchor="ctr"/>
           <a:lstStyle/>
           <a:p>
-            <a:pPr indent="0" marL="0">
+            <a:pPr marL="0" indent="0">
               <a:buNone/>
             </a:pPr>
             <a:r>
@@ -4572,6 +6098,13 @@
           </a:solidFill>
           <a:ln/>
         </p:spPr>
+        <p:txBody>
+          <a:bodyPr/>
+          <a:lstStyle/>
+          <a:p>
+            <a:endParaRPr lang="es-PE"/>
+          </a:p>
+        </p:txBody>
       </p:sp>
       <p:sp>
         <p:nvSpPr>
@@ -4594,7 +6127,7 @@
           <a:bodyPr wrap="square" lIns="0" tIns="0" rIns="0" bIns="0" rtlCol="0" anchor="t"/>
           <a:lstStyle/>
           <a:p>
-            <a:pPr algn="just" indent="0" marL="0">
+            <a:pPr marL="0" indent="0" algn="just">
               <a:lnSpc>
                 <a:spcPts val="2400"/>
               </a:lnSpc>
@@ -4623,7 +6156,7 @@
         </p:nvSpPr>
         <p:spPr>
           <a:xfrm>
-            <a:off x="886968" y="3611880"/>
+            <a:off x="886968" y="3383280"/>
             <a:ext cx="10405872" cy="1280160"/>
           </a:xfrm>
           <a:prstGeom prst="rect">
@@ -4636,7 +6169,7 @@
           <a:bodyPr wrap="square" lIns="0" tIns="0" rIns="0" bIns="0" rtlCol="0" anchor="t"/>
           <a:lstStyle/>
           <a:p>
-            <a:pPr algn="just" indent="0" marL="0">
+            <a:pPr marL="0" indent="0" algn="just">
               <a:lnSpc>
                 <a:spcPts val="2400"/>
               </a:lnSpc>
@@ -4665,7 +6198,7 @@
         </p:nvSpPr>
         <p:spPr>
           <a:xfrm>
-            <a:off x="886968" y="5074920"/>
+            <a:off x="886968" y="4614269"/>
             <a:ext cx="10405872" cy="1325880"/>
           </a:xfrm>
           <a:prstGeom prst="rect">
@@ -4681,6 +6214,13 @@
             <a:prstDash val="solid"/>
           </a:ln>
         </p:spPr>
+        <p:txBody>
+          <a:bodyPr/>
+          <a:lstStyle/>
+          <a:p>
+            <a:endParaRPr lang="es-PE"/>
+          </a:p>
+        </p:txBody>
       </p:sp>
       <p:sp>
         <p:nvSpPr>
@@ -4690,7 +6230,7 @@
         </p:nvSpPr>
         <p:spPr>
           <a:xfrm>
-            <a:off x="1161288" y="5257800"/>
+            <a:off x="1161288" y="4797149"/>
             <a:ext cx="2743200" cy="256032"/>
           </a:xfrm>
           <a:prstGeom prst="rect">
@@ -4703,7 +6243,7 @@
           <a:bodyPr wrap="square" lIns="0" tIns="0" rIns="0" bIns="0" rtlCol="0" anchor="ctr"/>
           <a:lstStyle/>
           <a:p>
-            <a:pPr indent="0" marL="0">
+            <a:pPr marL="0" indent="0">
               <a:buNone/>
             </a:pPr>
             <a:r>
@@ -4729,7 +6269,7 @@
         </p:nvSpPr>
         <p:spPr>
           <a:xfrm>
-            <a:off x="1161288" y="5559552"/>
+            <a:off x="1161288" y="5098901"/>
             <a:ext cx="9857232" cy="822960"/>
           </a:xfrm>
           <a:prstGeom prst="rect">
@@ -4742,7 +6282,7 @@
           <a:bodyPr wrap="square" lIns="0" tIns="0" rIns="0" bIns="0" rtlCol="0" anchor="t"/>
           <a:lstStyle/>
           <a:p>
-            <a:pPr algn="just" indent="0" marL="0">
+            <a:pPr marL="0" indent="0" algn="just">
               <a:lnSpc>
                 <a:spcPts val="2000"/>
               </a:lnSpc>
@@ -5064,4 +6604,319 @@
     </a:ext>
   </a:extLst>
 </a:theme>
+</file>
+
+<file path=ppt/theme/theme2.xml><?xml version="1.0" encoding="utf-8"?>
+<a:theme xmlns:a="http://schemas.openxmlformats.org/drawingml/2006/main" name="Tema de Office">
+  <a:themeElements>
+    <a:clrScheme name="Office">
+      <a:dk1>
+        <a:sysClr val="windowText" lastClr="000000"/>
+      </a:dk1>
+      <a:lt1>
+        <a:sysClr val="window" lastClr="FFFFFF"/>
+      </a:lt1>
+      <a:dk2>
+        <a:srgbClr val="0E2841"/>
+      </a:dk2>
+      <a:lt2>
+        <a:srgbClr val="E8E8E8"/>
+      </a:lt2>
+      <a:accent1>
+        <a:srgbClr val="156082"/>
+      </a:accent1>
+      <a:accent2>
+        <a:srgbClr val="E97132"/>
+      </a:accent2>
+      <a:accent3>
+        <a:srgbClr val="196B24"/>
+      </a:accent3>
+      <a:accent4>
+        <a:srgbClr val="0F9ED5"/>
+      </a:accent4>
+      <a:accent5>
+        <a:srgbClr val="A02B93"/>
+      </a:accent5>
+      <a:accent6>
+        <a:srgbClr val="4EA72E"/>
+      </a:accent6>
+      <a:hlink>
+        <a:srgbClr val="467886"/>
+      </a:hlink>
+      <a:folHlink>
+        <a:srgbClr val="96607D"/>
+      </a:folHlink>
+    </a:clrScheme>
+    <a:fontScheme name="Office">
+      <a:majorFont>
+        <a:latin typeface="Aptos Display" panose="02110004020202020204"/>
+        <a:ea typeface=""/>
+        <a:cs typeface=""/>
+        <a:font script="Jpan" typeface="游ゴシック Light"/>
+        <a:font script="Hang" typeface="맑은 고딕"/>
+        <a:font script="Hans" typeface="等线 Light"/>
+        <a:font script="Hant" typeface="新細明體"/>
+        <a:font script="Arab" typeface="Times New Roman"/>
+        <a:font script="Hebr" typeface="Times New Roman"/>
+        <a:font script="Thai" typeface="Angsana New"/>
+        <a:font script="Ethi" typeface="Nyala"/>
+        <a:font script="Beng" typeface="Vrinda"/>
+        <a:font script="Gujr" typeface="Shruti"/>
+        <a:font script="Khmr" typeface="MoolBoran"/>
+        <a:font script="Knda" typeface="Tunga"/>
+        <a:font script="Guru" typeface="Raavi"/>
+        <a:font script="Cans" typeface="Euphemia"/>
+        <a:font script="Cher" typeface="Plantagenet Cherokee"/>
+        <a:font script="Yiii" typeface="Microsoft Yi Baiti"/>
+        <a:font script="Tibt" typeface="Microsoft Himalaya"/>
+        <a:font script="Thaa" typeface="MV Boli"/>
+        <a:font script="Deva" typeface="Mangal"/>
+        <a:font script="Telu" typeface="Gautami"/>
+        <a:font script="Taml" typeface="Latha"/>
+        <a:font script="Syrc" typeface="Estrangelo Edessa"/>
+        <a:font script="Orya" typeface="Kalinga"/>
+        <a:font script="Mlym" typeface="Kartika"/>
+        <a:font script="Laoo" typeface="DokChampa"/>
+        <a:font script="Sinh" typeface="Iskoola Pota"/>
+        <a:font script="Mong" typeface="Mongolian Baiti"/>
+        <a:font script="Viet" typeface="Times New Roman"/>
+        <a:font script="Uigh" typeface="Microsoft Uighur"/>
+        <a:font script="Geor" typeface="Sylfaen"/>
+        <a:font script="Armn" typeface="Arial"/>
+        <a:font script="Bugi" typeface="Leelawadee UI"/>
+        <a:font script="Bopo" typeface="Microsoft JhengHei"/>
+        <a:font script="Java" typeface="Javanese Text"/>
+        <a:font script="Lisu" typeface="Segoe UI"/>
+        <a:font script="Mymr" typeface="Myanmar Text"/>
+        <a:font script="Nkoo" typeface="Ebrima"/>
+        <a:font script="Olck" typeface="Nirmala UI"/>
+        <a:font script="Osma" typeface="Ebrima"/>
+        <a:font script="Phag" typeface="Phagspa"/>
+        <a:font script="Syrn" typeface="Estrangelo Edessa"/>
+        <a:font script="Syrj" typeface="Estrangelo Edessa"/>
+        <a:font script="Syre" typeface="Estrangelo Edessa"/>
+        <a:font script="Sora" typeface="Nirmala UI"/>
+        <a:font script="Tale" typeface="Microsoft Tai Le"/>
+        <a:font script="Talu" typeface="Microsoft New Tai Lue"/>
+        <a:font script="Tfng" typeface="Ebrima"/>
+      </a:majorFont>
+      <a:minorFont>
+        <a:latin typeface="Aptos" panose="02110004020202020204"/>
+        <a:ea typeface=""/>
+        <a:cs typeface=""/>
+        <a:font script="Jpan" typeface="游ゴシック"/>
+        <a:font script="Hang" typeface="맑은 고딕"/>
+        <a:font script="Hans" typeface="等线"/>
+        <a:font script="Hant" typeface="新細明體"/>
+        <a:font script="Arab" typeface="Arial"/>
+        <a:font script="Hebr" typeface="Arial"/>
+        <a:font script="Thai" typeface="Cordia New"/>
+        <a:font script="Ethi" typeface="Nyala"/>
+        <a:font script="Beng" typeface="Vrinda"/>
+        <a:font script="Gujr" typeface="Shruti"/>
+        <a:font script="Khmr" typeface="DaunPenh"/>
+        <a:font script="Knda" typeface="Tunga"/>
+        <a:font script="Guru" typeface="Raavi"/>
+        <a:font script="Cans" typeface="Euphemia"/>
+        <a:font script="Cher" typeface="Plantagenet Cherokee"/>
+        <a:font script="Yiii" typeface="Microsoft Yi Baiti"/>
+        <a:font script="Tibt" typeface="Microsoft Himalaya"/>
+        <a:font script="Thaa" typeface="MV Boli"/>
+        <a:font script="Deva" typeface="Mangal"/>
+        <a:font script="Telu" typeface="Gautami"/>
+        <a:font script="Taml" typeface="Latha"/>
+        <a:font script="Syrc" typeface="Estrangelo Edessa"/>
+        <a:font script="Orya" typeface="Kalinga"/>
+        <a:font script="Mlym" typeface="Kartika"/>
+        <a:font script="Laoo" typeface="DokChampa"/>
+        <a:font script="Sinh" typeface="Iskoola Pota"/>
+        <a:font script="Mong" typeface="Mongolian Baiti"/>
+        <a:font script="Viet" typeface="Arial"/>
+        <a:font script="Uigh" typeface="Microsoft Uighur"/>
+        <a:font script="Geor" typeface="Sylfaen"/>
+        <a:font script="Armn" typeface="Arial"/>
+        <a:font script="Bugi" typeface="Leelawadee UI"/>
+        <a:font script="Bopo" typeface="Microsoft JhengHei"/>
+        <a:font script="Java" typeface="Javanese Text"/>
+        <a:font script="Lisu" typeface="Segoe UI"/>
+        <a:font script="Mymr" typeface="Myanmar Text"/>
+        <a:font script="Nkoo" typeface="Ebrima"/>
+        <a:font script="Olck" typeface="Nirmala UI"/>
+        <a:font script="Osma" typeface="Ebrima"/>
+        <a:font script="Phag" typeface="Phagspa"/>
+        <a:font script="Syrn" typeface="Estrangelo Edessa"/>
+        <a:font script="Syrj" typeface="Estrangelo Edessa"/>
+        <a:font script="Syre" typeface="Estrangelo Edessa"/>
+        <a:font script="Sora" typeface="Nirmala UI"/>
+        <a:font script="Tale" typeface="Microsoft Tai Le"/>
+        <a:font script="Talu" typeface="Microsoft New Tai Lue"/>
+        <a:font script="Tfng" typeface="Ebrima"/>
+      </a:minorFont>
+    </a:fontScheme>
+    <a:fmtScheme name="Office">
+      <a:fillStyleLst>
+        <a:solidFill>
+          <a:schemeClr val="phClr"/>
+        </a:solidFill>
+        <a:gradFill rotWithShape="1">
+          <a:gsLst>
+            <a:gs pos="0">
+              <a:schemeClr val="phClr">
+                <a:lumMod val="110000"/>
+                <a:satMod val="105000"/>
+                <a:tint val="67000"/>
+              </a:schemeClr>
+            </a:gs>
+            <a:gs pos="50000">
+              <a:schemeClr val="phClr">
+                <a:lumMod val="105000"/>
+                <a:satMod val="103000"/>
+                <a:tint val="73000"/>
+              </a:schemeClr>
+            </a:gs>
+            <a:gs pos="100000">
+              <a:schemeClr val="phClr">
+                <a:lumMod val="105000"/>
+                <a:satMod val="109000"/>
+                <a:tint val="81000"/>
+              </a:schemeClr>
+            </a:gs>
+          </a:gsLst>
+          <a:lin ang="5400000" scaled="0"/>
+        </a:gradFill>
+        <a:gradFill rotWithShape="1">
+          <a:gsLst>
+            <a:gs pos="0">
+              <a:schemeClr val="phClr">
+                <a:satMod val="103000"/>
+                <a:lumMod val="102000"/>
+                <a:tint val="94000"/>
+              </a:schemeClr>
+            </a:gs>
+            <a:gs pos="50000">
+              <a:schemeClr val="phClr">
+                <a:satMod val="110000"/>
+                <a:lumMod val="100000"/>
+                <a:shade val="100000"/>
+              </a:schemeClr>
+            </a:gs>
+            <a:gs pos="100000">
+              <a:schemeClr val="phClr">
+                <a:lumMod val="99000"/>
+                <a:satMod val="120000"/>
+                <a:shade val="78000"/>
+              </a:schemeClr>
+            </a:gs>
+          </a:gsLst>
+          <a:lin ang="5400000" scaled="0"/>
+        </a:gradFill>
+      </a:fillStyleLst>
+      <a:lnStyleLst>
+        <a:ln w="12700" cap="flat" cmpd="sng" algn="ctr">
+          <a:solidFill>
+            <a:schemeClr val="phClr"/>
+          </a:solidFill>
+          <a:prstDash val="solid"/>
+          <a:miter lim="800000"/>
+        </a:ln>
+        <a:ln w="19050" cap="flat" cmpd="sng" algn="ctr">
+          <a:solidFill>
+            <a:schemeClr val="phClr"/>
+          </a:solidFill>
+          <a:prstDash val="solid"/>
+          <a:miter lim="800000"/>
+        </a:ln>
+        <a:ln w="25400" cap="flat" cmpd="sng" algn="ctr">
+          <a:solidFill>
+            <a:schemeClr val="phClr"/>
+          </a:solidFill>
+          <a:prstDash val="solid"/>
+          <a:miter lim="800000"/>
+        </a:ln>
+      </a:lnStyleLst>
+      <a:effectStyleLst>
+        <a:effectStyle>
+          <a:effectLst/>
+        </a:effectStyle>
+        <a:effectStyle>
+          <a:effectLst/>
+        </a:effectStyle>
+        <a:effectStyle>
+          <a:effectLst>
+            <a:outerShdw blurRad="57150" dist="19050" dir="5400000" algn="ctr" rotWithShape="0">
+              <a:srgbClr val="000000">
+                <a:alpha val="63000"/>
+              </a:srgbClr>
+            </a:outerShdw>
+          </a:effectLst>
+        </a:effectStyle>
+      </a:effectStyleLst>
+      <a:bgFillStyleLst>
+        <a:solidFill>
+          <a:schemeClr val="phClr"/>
+        </a:solidFill>
+        <a:solidFill>
+          <a:schemeClr val="phClr">
+            <a:tint val="95000"/>
+            <a:satMod val="170000"/>
+          </a:schemeClr>
+        </a:solidFill>
+        <a:gradFill rotWithShape="1">
+          <a:gsLst>
+            <a:gs pos="0">
+              <a:schemeClr val="phClr">
+                <a:tint val="93000"/>
+                <a:satMod val="150000"/>
+                <a:shade val="98000"/>
+                <a:lumMod val="102000"/>
+              </a:schemeClr>
+            </a:gs>
+            <a:gs pos="50000">
+              <a:schemeClr val="phClr">
+                <a:tint val="98000"/>
+                <a:satMod val="130000"/>
+                <a:shade val="90000"/>
+                <a:lumMod val="103000"/>
+              </a:schemeClr>
+            </a:gs>
+            <a:gs pos="100000">
+              <a:schemeClr val="phClr">
+                <a:shade val="63000"/>
+                <a:satMod val="120000"/>
+              </a:schemeClr>
+            </a:gs>
+          </a:gsLst>
+          <a:lin ang="5400000" scaled="0"/>
+        </a:gradFill>
+      </a:bgFillStyleLst>
+    </a:fmtScheme>
+  </a:themeElements>
+  <a:objectDefaults>
+    <a:lnDef>
+      <a:spPr/>
+      <a:bodyPr/>
+      <a:lstStyle/>
+      <a:style>
+        <a:lnRef idx="2">
+          <a:schemeClr val="accent1"/>
+        </a:lnRef>
+        <a:fillRef idx="0">
+          <a:schemeClr val="accent1"/>
+        </a:fillRef>
+        <a:effectRef idx="1">
+          <a:schemeClr val="accent1"/>
+        </a:effectRef>
+        <a:fontRef idx="minor">
+          <a:schemeClr val="tx1"/>
+        </a:fontRef>
+      </a:style>
+    </a:lnDef>
+  </a:objectDefaults>
+  <a:extraClrSchemeLst/>
+  <a:extLst>
+    <a:ext uri="{05A4C25C-085E-4340-85A3-A5531E510DB2}">
+      <thm15:themeFamily xmlns:thm15="http://schemas.microsoft.com/office/thememl/2012/main" name="Office Theme" id="{2E142A2C-CD16-42D6-873A-C26D2A0506FA}" vid="{1BDDFF52-6CD6-40A5-AB3C-68EB2F1E4D0A}"/>
+    </a:ext>
+  </a:extLst>
+</a:theme>
 </file>
</xml_diff>